<commit_message>
docs(ppt): Korean narrative + future plans / target metrics / risks
Translate the insights deck to Korean (technical terms kept in English where
they are standard). Add four new slides covering next steps:

  - 향후 진행 계획: Plan 5 (data) / Plan 6 (alignment-preserving fine-tune,
    conditional on Plan 5 outcome) / Plan 7 (classifier, SR — optional).
  - 예상 결과: target MAE per stage with explicit current vs target numbers
    for apple / pear / bagged-fruit domains.
  - 진입 조건 및 타임라인: preconditions and rough effort estimates.
  - 리스크 및 감지 지표: R1-R4 with in-flight detection metrics.

Deck is now 26 slides.
</commit_message>
<xml_diff>
--- a/docs/presentations/fruit_counting_insights.pptx
+++ b/docs/presentations/fruit_counting_insights.pptx
@@ -26,6 +26,10 @@
     <p:sldId id="274" r:id="rId25"/>
     <p:sldId id="275" r:id="rId26"/>
     <p:sldId id="276" r:id="rId27"/>
+    <p:sldId id="277" r:id="rId28"/>
+    <p:sldId id="278" r:id="rId29"/>
+    <p:sldId id="279" r:id="rId30"/>
+    <p:sldId id="280" r:id="rId31"/>
   </p:sldIdLst>
   <p:sldSz cx="12191695" cy="6858000" type="screen4x3"/>
   <p:notesSz cx="6858000" cy="9144000"/>
@@ -3137,8 +3141,8 @@
                   <a:srgbClr val="1F3B5C"/>
                 </a:solidFill>
               </a:rPr>
-              <a:t>Fruit Counting with PseCo:
-A Case Study in CLIP-Aligned Classification</a:t>
+              <a:t>PseCo 기반 과일 카운팅:
+CLIP 정렬 분류기에 대한 사례 연구</a:t>
             </a:r>
           </a:p>
         </p:txBody>
@@ -3172,7 +3176,7 @@
                   <a:srgbClr val="6B6B6B"/>
                 </a:solidFill>
               </a:rPr>
-              <a:t>Theoretical background + insights from four iterations of training, diagnosis, and production engineering on orchard imagery</a:t>
+              <a:t>네 번의 학습·진단·프로덕션 이터레이션에서 얻은 이론적 배경과 핵심 인사이트 — 과수원 이미지 기반</a:t>
             </a:r>
           </a:p>
         </p:txBody>
@@ -3205,7 +3209,7 @@
                   <a:srgbClr val="6B6B6B"/>
                 </a:solidFill>
               </a:rPr>
-              <a:t>Internal research notes · 2026-04-22</a:t>
+              <a:t>내부 연구 노트 · 2026-04-22</a:t>
             </a:r>
           </a:p>
         </p:txBody>
@@ -3266,7 +3270,7 @@
                   <a:srgbClr val="1F3B5C"/>
                 </a:solidFill>
               </a:rPr>
-              <a:t>Insights from the Failure Modes</a:t>
+              <a:t>실패 모드에서 얻은 인사이트</a:t>
             </a:r>
           </a:p>
         </p:txBody>
@@ -3317,7 +3321,7 @@
                   <a:srgbClr val="2E5F8A"/>
                 </a:solidFill>
               </a:rPr>
-              <a:t>Insight 1 — "Predict Zero" is a Deceptive Baseline</a:t>
+              <a:t>인사이트 1 — "Predict Zero"는 기만적 baseline</a:t>
             </a:r>
           </a:p>
         </p:txBody>
@@ -3351,40 +3355,40 @@
                   <a:srgbClr val="2A2A2A"/>
                 </a:solidFill>
               </a:rPr>
-              <a:t>• On count datasets, predicting 0 for every image gives MAE = E[GT count].</a:t>
-            </a:r>
-          </a:p>
-          <a:p>
-            <a:pPr lvl="1"/>
-            <a:r>
-              <a:rPr sz="1500">
-                <a:solidFill>
-                  <a:srgbClr val="6B6B6B"/>
-                </a:solidFill>
-              </a:rPr>
-              <a:t>– For FSC-147 val, mean GT count ≈ 50.58.</a:t>
-            </a:r>
-          </a:p>
-          <a:p>
-            <a:pPr lvl="1"/>
-            <a:r>
-              <a:rPr sz="1500">
-                <a:solidFill>
-                  <a:srgbClr val="6B6B6B"/>
-                </a:solidFill>
-              </a:rPr>
-              <a:t>– Plan 2's placeholder trainer produced `val/mae = 50.58` constant across epochs.</a:t>
-            </a:r>
-          </a:p>
-          <a:p>
-            <a:pPr lvl="1"/>
-            <a:r>
-              <a:rPr sz="1500">
-                <a:solidFill>
-                  <a:srgbClr val="6B6B6B"/>
-                </a:solidFill>
-              </a:rPr>
-              <a:t>– Naive reading: "training is stuck at a non-trivial loss". True reading: model is collapsed.</a:t>
+              <a:t>• 카운팅 데이터셋에서 모든 이미지에 0 예측 시 MAE = E[GT count].</a:t>
+            </a:r>
+          </a:p>
+          <a:p>
+            <a:pPr lvl="1"/>
+            <a:r>
+              <a:rPr sz="1500">
+                <a:solidFill>
+                  <a:srgbClr val="6B6B6B"/>
+                </a:solidFill>
+              </a:rPr>
+              <a:t>– FSC-147 val 기준 평균 GT 개수 ≈ 50.58.</a:t>
+            </a:r>
+          </a:p>
+          <a:p>
+            <a:pPr lvl="1"/>
+            <a:r>
+              <a:rPr sz="1500">
+                <a:solidFill>
+                  <a:srgbClr val="6B6B6B"/>
+                </a:solidFill>
+              </a:rPr>
+              <a:t>– Plan 2의 placeholder 트레이너가 매 에폭 `val/mae = 50.58`을 유지.</a:t>
+            </a:r>
+          </a:p>
+          <a:p>
+            <a:pPr lvl="1"/>
+            <a:r>
+              <a:rPr sz="1500">
+                <a:solidFill>
+                  <a:srgbClr val="6B6B6B"/>
+                </a:solidFill>
+              </a:rPr>
+              <a:t>– 순진한 해석: "자명하지 않은 손실에서 정체". 실제로는 모델이 붕괴한 상태.</a:t>
             </a:r>
           </a:p>
           <a:p>
@@ -3395,18 +3399,18 @@
                   <a:srgbClr val="2A2A2A"/>
                 </a:solidFill>
               </a:rPr>
-              <a:t>• Plan 3 produced `val/mae = 47.62` — only marginally better than zero-prediction.</a:t>
-            </a:r>
-          </a:p>
-          <a:p>
-            <a:pPr lvl="1"/>
-            <a:r>
-              <a:rPr sz="1500">
-                <a:solidFill>
-                  <a:srgbClr val="6B6B6B"/>
-                </a:solidFill>
-              </a:rPr>
-              <a:t>– We celebrated this as beating baseline; it was actually still ~93% of the zero-prediction error.</a:t>
+              <a:t>• Plan 3의 `val/mae = 47.62` — zero-prediction 대비 겨우 한 자릿수 개선.</a:t>
+            </a:r>
+          </a:p>
+          <a:p>
+            <a:pPr lvl="1"/>
+            <a:r>
+              <a:rPr sz="1500">
+                <a:solidFill>
+                  <a:srgbClr val="6B6B6B"/>
+                </a:solidFill>
+              </a:rPr>
+              <a:t>– 처음에는 baseline 돌파로 축하했지만, 사실상 여전히 zero-prediction 오차의 93% 수준.</a:t>
             </a:r>
           </a:p>
           <a:p>
@@ -3417,29 +3421,29 @@
                   <a:srgbClr val="2A2A2A"/>
                 </a:solidFill>
               </a:rPr>
-              <a:t>• Research implication: for counting tasks, report MAE relative to predict-zero AND relative to predict-mean.</a:t>
-            </a:r>
-          </a:p>
-          <a:p>
-            <a:pPr lvl="1"/>
-            <a:r>
-              <a:rPr sz="1500">
-                <a:solidFill>
-                  <a:srgbClr val="6B6B6B"/>
-                </a:solidFill>
-              </a:rPr>
-              <a:t>– A model that beats predict-zero but not predict-mean is probably memorizing the dataset mean.</a:t>
-            </a:r>
-          </a:p>
-          <a:p>
-            <a:pPr lvl="1"/>
-            <a:r>
-              <a:rPr sz="1500">
-                <a:solidFill>
-                  <a:srgbClr val="6B6B6B"/>
-                </a:solidFill>
-              </a:rPr>
-              <a:t>– A convergence metric should subtract that trivial baseline explicitly.</a:t>
+              <a:t>• 연구적 함의: 카운팅에서는 predict-zero와 predict-mean 두 기준선을 모두 리포트해야 함.</a:t>
+            </a:r>
+          </a:p>
+          <a:p>
+            <a:pPr lvl="1"/>
+            <a:r>
+              <a:rPr sz="1500">
+                <a:solidFill>
+                  <a:srgbClr val="6B6B6B"/>
+                </a:solidFill>
+              </a:rPr>
+              <a:t>– predict-zero를 이기지만 predict-mean을 못 이기면, 단순히 데이터셋 평균을 학습한 것일 수 있음.</a:t>
+            </a:r>
+          </a:p>
+          <a:p>
+            <a:pPr lvl="1"/>
+            <a:r>
+              <a:rPr sz="1500">
+                <a:solidFill>
+                  <a:srgbClr val="6B6B6B"/>
+                </a:solidFill>
+              </a:rPr>
+              <a:t>– 수렴 지표는 이 자명한 기준선을 명시적으로 차감한 형태여야 함.</a:t>
             </a:r>
           </a:p>
         </p:txBody>
@@ -3490,7 +3494,7 @@
                   <a:srgbClr val="2E5F8A"/>
                 </a:solidFill>
               </a:rPr>
-              <a:t>Insight 2 — CLIP Alignment is Fragile Under Naive Fine-tuning</a:t>
+              <a:t>인사이트 2 — CLIP 정렬은 순진한 파인튜닝에 취약함</a:t>
             </a:r>
           </a:p>
         </p:txBody>
@@ -3524,7 +3528,7 @@
                   <a:srgbClr val="2A2A2A"/>
                 </a:solidFill>
               </a:rPr>
-              <a:t>• Plan 3 training: one class per image, binary cross-entropy on (positive / negative) proposal labels.</a:t>
+              <a:t>• Plan 3 학습: 이미지당 하나의 클래스, proposal의 (pos/neg) 레이블에 대한 binary cross-entropy.</a:t>
             </a:r>
           </a:p>
           <a:p>
@@ -3535,29 +3539,29 @@
                   <a:srgbClr val="2A2A2A"/>
                 </a:solidFill>
               </a:rPr>
-              <a:t>• Result: fine-tuned MLP became prompt-agnostic.</a:t>
-            </a:r>
-          </a:p>
-          <a:p>
-            <a:pPr lvl="1"/>
-            <a:r>
-              <a:rPr sz="1500">
-                <a:solidFill>
-                  <a:srgbClr val="6B6B6B"/>
-                </a:solidFill>
-              </a:rPr>
-              <a:t>– `apples`, `apple in paper bag`, `protective fruit bag` all produced ~500 predictions on same apple image.</a:t>
-            </a:r>
-          </a:p>
-          <a:p>
-            <a:pPr lvl="1"/>
-            <a:r>
-              <a:rPr sz="1500">
-                <a:solidFill>
-                  <a:srgbClr val="6B6B6B"/>
-                </a:solidFill>
-              </a:rPr>
-              <a:t>– Upstream MLP in contrast distinguishes: 6 / 25 / 8 on the same image.</a:t>
+              <a:t>• 결과: 파인튜닝된 MLP가 프롬프트에 무감각해짐.</a:t>
+            </a:r>
+          </a:p>
+          <a:p>
+            <a:pPr lvl="1"/>
+            <a:r>
+              <a:rPr sz="1500">
+                <a:solidFill>
+                  <a:srgbClr val="6B6B6B"/>
+                </a:solidFill>
+              </a:rPr>
+              <a:t>– 같은 사과 이미지에서 `apples`, `apple in paper bag`, `protective fruit bag` 모두 ~500개 예측.</a:t>
+            </a:r>
+          </a:p>
+          <a:p>
+            <a:pPr lvl="1"/>
+            <a:r>
+              <a:rPr sz="1500">
+                <a:solidFill>
+                  <a:srgbClr val="6B6B6B"/>
+                </a:solidFill>
+              </a:rPr>
+              <a:t>– Upstream MLP는 동일 이미지에서 6 / 25 / 8로 프롬프트를 구분.</a:t>
             </a:r>
           </a:p>
           <a:p>
@@ -3568,29 +3572,29 @@
                   <a:srgbClr val="2A2A2A"/>
                 </a:solidFill>
               </a:rPr>
-              <a:t>• Mechanism: binary CE with only one active class drives the head to ignore text features.</a:t>
-            </a:r>
-          </a:p>
-          <a:p>
-            <a:pPr lvl="1"/>
-            <a:r>
-              <a:rPr sz="1500">
-                <a:solidFill>
-                  <a:srgbClr val="6B6B6B"/>
-                </a:solidFill>
-              </a:rPr>
-              <a:t>– Gradient only penalizes 'visual feature says positive/negative', never 'text agrees/disagrees'.</a:t>
-            </a:r>
-          </a:p>
-          <a:p>
-            <a:pPr lvl="1"/>
-            <a:r>
-              <a:rPr sz="1500">
-                <a:solidFill>
-                  <a:srgbClr val="6B6B6B"/>
-                </a:solidFill>
-              </a:rPr>
-              <a:t>– CLIP alignment in the pretrained weights slowly decays during fine-tuning.</a:t>
+              <a:t>• 메커니즘: 단일 클래스 binary CE 기울기는 "시각 특징이 pos/neg"만 학습, 텍스트 정렬 신호는 무시됨.</a:t>
+            </a:r>
+          </a:p>
+          <a:p>
+            <a:pPr lvl="1"/>
+            <a:r>
+              <a:rPr sz="1500">
+                <a:solidFill>
+                  <a:srgbClr val="6B6B6B"/>
+                </a:solidFill>
+              </a:rPr>
+              <a:t>– 그래디언트가 'CLIP 텍스트 일치/불일치'를 한 번도 처벌하지 않음.</a:t>
+            </a:r>
+          </a:p>
+          <a:p>
+            <a:pPr lvl="1"/>
+            <a:r>
+              <a:rPr sz="1500">
+                <a:solidFill>
+                  <a:srgbClr val="6B6B6B"/>
+                </a:solidFill>
+              </a:rPr>
+              <a:t>– Pretrained의 CLIP 정렬이 파인튜닝 동안 서서히 decay.</a:t>
             </a:r>
           </a:p>
           <a:p>
@@ -3601,29 +3605,29 @@
                   <a:srgbClr val="2A2A2A"/>
                 </a:solidFill>
               </a:rPr>
-              <a:t>• Upstream PseCo's training uses a secondary CLIP consistency loss (`cls_loss2`) — we skipped this.</a:t>
-            </a:r>
-          </a:p>
-          <a:p>
-            <a:pPr lvl="1"/>
-            <a:r>
-              <a:rPr sz="1500">
-                <a:solidFill>
-                  <a:srgbClr val="6B6B6B"/>
-                </a:solidFill>
-              </a:rPr>
-              <a:t>– Research question: can we quantify CLIP alignment loss during fine-tuning and stop early?</a:t>
-            </a:r>
-          </a:p>
-          <a:p>
-            <a:pPr lvl="1"/>
-            <a:r>
-              <a:rPr sz="1500">
-                <a:solidFill>
-                  <a:srgbClr val="6B6B6B"/>
-                </a:solidFill>
-              </a:rPr>
-              <a:t>– Candidate metric: prompt-discrimination score on a held-out triplet (image, correct class, wrong class).</a:t>
+              <a:t>• Upstream PseCo는 보조 CLIP 일관성 손실(`cls_loss2`)을 씀 — 우리는 생략했고 결과는 위와 같음.</a:t>
+            </a:r>
+          </a:p>
+          <a:p>
+            <a:pPr lvl="1"/>
+            <a:r>
+              <a:rPr sz="1500">
+                <a:solidFill>
+                  <a:srgbClr val="6B6B6B"/>
+                </a:solidFill>
+              </a:rPr>
+              <a:t>– 연구 질문: 파인튜닝 동안 CLIP 정렬 손실을 정량화해 조기 중단 기준으로 쓸 수 있는가?</a:t>
+            </a:r>
+          </a:p>
+          <a:p>
+            <a:pPr lvl="1"/>
+            <a:r>
+              <a:rPr sz="1500">
+                <a:solidFill>
+                  <a:srgbClr val="6B6B6B"/>
+                </a:solidFill>
+              </a:rPr>
+              <a:t>– 후보 지표: 고정된 triplet (이미지, 정답 클래스, 오답 클래스)에 대한 prompt-discrimination 점수.</a:t>
             </a:r>
           </a:p>
         </p:txBody>
@@ -3674,7 +3678,7 @@
                   <a:srgbClr val="2E5F8A"/>
                 </a:solidFill>
               </a:rPr>
-              <a:t>Insight 3 — Coordinate-System Bugs Silently Waste Training</a:t>
+              <a:t>인사이트 3 — 좌표계 버그가 학습을 조용히 낭비시킴</a:t>
             </a:r>
           </a:p>
         </p:txBody>
@@ -3708,7 +3712,7 @@
                   <a:srgbClr val="2A2A2A"/>
                 </a:solidFill>
               </a:rPr>
-              <a:t>• Plan 3 labels came from FSC-147 point annotations in original image space (longest side = 384 px).</a:t>
+              <a:t>• Plan 3의 레이블은 FSC-147 점 어노테이션(원본 이미지 좌표계, 긴 변 384 px) 기반.</a:t>
             </a:r>
           </a:p>
           <a:p>
@@ -3719,29 +3723,29 @@
                   <a:srgbClr val="2A2A2A"/>
                 </a:solidFill>
               </a:rPr>
-              <a:t>• PointDecoder predictions came from SAM's 1024-px padded space.</a:t>
-            </a:r>
-          </a:p>
-          <a:p>
-            <a:pPr lvl="1"/>
-            <a:r>
-              <a:rPr sz="1500">
-                <a:solidFill>
-                  <a:srgbClr val="6B6B6B"/>
-                </a:solidFill>
-              </a:rPr>
-              <a:t>– Box-point containment check compared them as if they were in the same coordinate frame.</a:t>
-            </a:r>
-          </a:p>
-          <a:p>
-            <a:pPr lvl="1"/>
-            <a:r>
-              <a:rPr sz="1500">
-                <a:solidFill>
-                  <a:srgbClr val="6B6B6B"/>
-                </a:solidFill>
-              </a:rPr>
-              <a:t>– Almost no containment hits. Nearly all proposals labeled negative.</a:t>
+              <a:t>• PointDecoder 예측은 SAM의 1024-px padding 좌표계.</a:t>
+            </a:r>
+          </a:p>
+          <a:p>
+            <a:pPr lvl="1"/>
+            <a:r>
+              <a:rPr sz="1500">
+                <a:solidFill>
+                  <a:srgbClr val="6B6B6B"/>
+                </a:solidFill>
+              </a:rPr>
+              <a:t>– 점-박스 포함 체크가 두 좌표계를 같은 프레임으로 가정해 비교.</a:t>
+            </a:r>
+          </a:p>
+          <a:p>
+            <a:pPr lvl="1"/>
+            <a:r>
+              <a:rPr sz="1500">
+                <a:solidFill>
+                  <a:srgbClr val="6B6B6B"/>
+                </a:solidFill>
+              </a:rPr>
+              <a:t>– 포함 판정이 거의 일어나지 않음 → 대부분 proposal이 negative로 분류.</a:t>
             </a:r>
           </a:p>
           <a:p>
@@ -3752,18 +3756,18 @@
                   <a:srgbClr val="2A2A2A"/>
                 </a:solidFill>
               </a:rPr>
-              <a:t>• Symptom: training loss went down (easy to say 'all negative'), val/mae stuck at 62–63.</a:t>
-            </a:r>
-          </a:p>
-          <a:p>
-            <a:pPr lvl="1"/>
-            <a:r>
-              <a:rPr sz="1500">
-                <a:solidFill>
-                  <a:srgbClr val="6B6B6B"/>
-                </a:solidFill>
-              </a:rPr>
-              <a:t>– A bug that SAVES MONEY on loss by making the problem trivially learnable.</a:t>
+              <a:t>• 증상: 학습 loss는 내려감 (모두 negative라고 답하면 쉬움), val/mae는 62-63에서 정체.</a:t>
+            </a:r>
+          </a:p>
+          <a:p>
+            <a:pPr lvl="1"/>
+            <a:r>
+              <a:rPr sz="1500">
+                <a:solidFill>
+                  <a:srgbClr val="6B6B6B"/>
+                </a:solidFill>
+              </a:rPr>
+              <a:t>– 문제를 "쉽게 학습 가능하게 만들어서 loss를 줄이는" 버그.</a:t>
             </a:r>
           </a:p>
           <a:p>
@@ -3774,7 +3778,7 @@
                   <a:srgbClr val="2A2A2A"/>
                 </a:solidFill>
               </a:rPr>
-              <a:t>• Fix: scale GT points to 1024 space via `1024 / max(H, W)`. Single commit, val/mae dropped 62.79 → 54.26.</a:t>
+              <a:t>• 수정: GT 점을 `1024 / max(H, W)` 배로 1024 공간에 스케일링. 한 커밋으로 val/mae 62.79 → 54.26.</a:t>
             </a:r>
           </a:p>
           <a:p>
@@ -3785,29 +3789,29 @@
                   <a:srgbClr val="2A2A2A"/>
                 </a:solidFill>
               </a:rPr>
-              <a:t>• Research-engineering lesson:</a:t>
-            </a:r>
-          </a:p>
-          <a:p>
-            <a:pPr lvl="1"/>
-            <a:r>
-              <a:rPr sz="1500">
-                <a:solidFill>
-                  <a:srgbClr val="6B6B6B"/>
-                </a:solidFill>
-              </a:rPr>
-              <a:t>– Multi-module pipelines mix coordinate frames silently. Write a single test that asserts frame equality.</a:t>
-            </a:r>
-          </a:p>
-          <a:p>
-            <a:pPr lvl="1"/>
-            <a:r>
-              <a:rPr sz="1500">
-                <a:solidFill>
-                  <a:srgbClr val="6B6B6B"/>
-                </a:solidFill>
-              </a:rPr>
-              <a:t>– "Losses going down" alone is NEVER evidence of correctness.</a:t>
+              <a:t>• 연구·엔지니어링 교훈:</a:t>
+            </a:r>
+          </a:p>
+          <a:p>
+            <a:pPr lvl="1"/>
+            <a:r>
+              <a:rPr sz="1500">
+                <a:solidFill>
+                  <a:srgbClr val="6B6B6B"/>
+                </a:solidFill>
+              </a:rPr>
+              <a:t>– 멀티모듈 파이프라인은 좌표 프레임을 조용히 섞음. 프레임 일치를 주장하는 단일 테스트를 써야 함.</a:t>
+            </a:r>
+          </a:p>
+          <a:p>
+            <a:pPr lvl="1"/>
+            <a:r>
+              <a:rPr sz="1500">
+                <a:solidFill>
+                  <a:srgbClr val="6B6B6B"/>
+                </a:solidFill>
+              </a:rPr>
+              <a:t>– "loss가 내려감" 자체는 절대로 정확성의 증거가 아님.</a:t>
             </a:r>
           </a:p>
         </p:txBody>
@@ -3858,7 +3862,7 @@
                   <a:srgbClr val="2E5F8A"/>
                 </a:solidFill>
               </a:rPr>
-              <a:t>Insight 4 — QuickGELU vs GELU: a 0.3% Activation Difference with 100% Semantic Drift</a:t>
+              <a:t>인사이트 4 — QuickGELU vs GELU: 활성화 0.3% 차이, 의미 100% drift</a:t>
             </a:r>
           </a:p>
         </p:txBody>
@@ -3892,7 +3896,7 @@
                   <a:srgbClr val="2A2A2A"/>
                 </a:solidFill>
               </a:rPr>
-              <a:t>• OpenAI's original CLIP was trained with QuickGELU: `x * sigmoid(1.702 * x)`.</a:t>
+              <a:t>• OpenAI의 원본 CLIP은 QuickGELU로 학습됨: `x * sigmoid(1.702 * x)`.</a:t>
             </a:r>
           </a:p>
           <a:p>
@@ -3903,29 +3907,29 @@
                   <a:srgbClr val="2A2A2A"/>
                 </a:solidFill>
               </a:rPr>
-              <a:t>• `open_clip.create_model('ViT-B-32', pretrained='openai')` defaults to standard GELU.</a:t>
-            </a:r>
-          </a:p>
-          <a:p>
-            <a:pPr lvl="1"/>
-            <a:r>
-              <a:rPr sz="1500">
-                <a:solidFill>
-                  <a:srgbClr val="6B6B6B"/>
-                </a:solidFill>
-              </a:rPr>
-              <a:t>– Text embeddings change by only ~2% in L2 distance.</a:t>
-            </a:r>
-          </a:p>
-          <a:p>
-            <a:pPr lvl="1"/>
-            <a:r>
-              <a:rPr sz="1500">
-                <a:solidFill>
-                  <a:srgbClr val="6B6B6B"/>
-                </a:solidFill>
-              </a:rPr>
-              <a:t>– But the fine-tuned MLP head, trained in downstream tasks against the QuickGELU-derived embeddings, is spec-mismatched.</a:t>
+              <a:t>• `open_clip.create_model('ViT-B-32', pretrained='openai')` 기본값은 표준 GELU.</a:t>
+            </a:r>
+          </a:p>
+          <a:p>
+            <a:pPr lvl="1"/>
+            <a:r>
+              <a:rPr sz="1500">
+                <a:solidFill>
+                  <a:srgbClr val="6B6B6B"/>
+                </a:solidFill>
+              </a:rPr>
+              <a:t>– 텍스트 임베딩은 L2 기준 ~2%만 바뀜.</a:t>
+            </a:r>
+          </a:p>
+          <a:p>
+            <a:pPr lvl="1"/>
+            <a:r>
+              <a:rPr sz="1500">
+                <a:solidFill>
+                  <a:srgbClr val="6B6B6B"/>
+                </a:solidFill>
+              </a:rPr>
+              <a:t>– 하지만 QuickGELU 임베딩 위에서 학습된 MLP 헤드와 스펙이 맞지 않게 됨.</a:t>
             </a:r>
           </a:p>
           <a:p>
@@ -3936,29 +3940,29 @@
                   <a:srgbClr val="2A2A2A"/>
                 </a:solidFill>
               </a:rPr>
-              <a:t>• Upstream PseCo's `MLP_small_box_w1_zeroshot.tar` was trained with QuickGELU CLIP features.</a:t>
-            </a:r>
-          </a:p>
-          <a:p>
-            <a:pPr lvl="1"/>
-            <a:r>
-              <a:rPr sz="1500">
-                <a:solidFill>
-                  <a:srgbClr val="6B6B6B"/>
-                </a:solidFill>
-              </a:rPr>
-              <a:t>– We loaded it against standard-GELU features for 2 training runs before spotting the warning.</a:t>
-            </a:r>
-          </a:p>
-          <a:p>
-            <a:pPr lvl="1"/>
-            <a:r>
-              <a:rPr sz="1500">
-                <a:solidFill>
-                  <a:srgbClr val="6B6B6B"/>
-                </a:solidFill>
-              </a:rPr>
-              <a:t>– Fixing this alone was not enough to recover CLIP alignment (see Insight 2), but it is a necessary condition.</a:t>
+              <a:t>• Upstream PseCo `MLP_small_box_w1_zeroshot.tar` 은 QuickGELU CLIP 피처로 학습됨.</a:t>
+            </a:r>
+          </a:p>
+          <a:p>
+            <a:pPr lvl="1"/>
+            <a:r>
+              <a:rPr sz="1500">
+                <a:solidFill>
+                  <a:srgbClr val="6B6B6B"/>
+                </a:solidFill>
+              </a:rPr>
+              <a:t>– 우리는 경고를 놓친 채 표준-GELU 피처로 2번의 학습 런을 돌림.</a:t>
+            </a:r>
+          </a:p>
+          <a:p>
+            <a:pPr lvl="1"/>
+            <a:r>
+              <a:rPr sz="1500">
+                <a:solidFill>
+                  <a:srgbClr val="6B6B6B"/>
+                </a:solidFill>
+              </a:rPr>
+              <a:t>– 이 수정만으로 CLIP 정렬을 회복하진 못했지만(인사이트 2 참조), 필요조건임.</a:t>
             </a:r>
           </a:p>
           <a:p>
@@ -3969,18 +3973,18 @@
                   <a:srgbClr val="2A2A2A"/>
                 </a:solidFill>
               </a:rPr>
-              <a:t>• Research-engineering lesson:</a:t>
-            </a:r>
-          </a:p>
-          <a:p>
-            <a:pPr lvl="1"/>
-            <a:r>
-              <a:rPr sz="1500">
-                <a:solidFill>
-                  <a:srgbClr val="6B6B6B"/>
-                </a:solidFill>
-              </a:rPr>
-              <a:t>– Treat activation-variant tags in pretrained models as semver-breaking. Document them in checkpoints.</a:t>
+              <a:t>• 연구·엔지니어링 교훈:</a:t>
+            </a:r>
+          </a:p>
+          <a:p>
+            <a:pPr lvl="1"/>
+            <a:r>
+              <a:rPr sz="1500">
+                <a:solidFill>
+                  <a:srgbClr val="6B6B6B"/>
+                </a:solidFill>
+              </a:rPr>
+              <a:t>– 사전학습 모델의 activation variant 태그는 semver-breaking으로 취급해야 함. 체크포인트 메타에 명시.</a:t>
             </a:r>
           </a:p>
         </p:txBody>
@@ -4031,7 +4035,7 @@
                   <a:srgbClr val="2E5F8A"/>
                 </a:solidFill>
               </a:rPr>
-              <a:t>Insight 5 — SAM Anchor Size Must Match Object Scale</a:t>
+              <a:t>인사이트 5 — SAM anchor size는 객체 스케일에 맞아야 함</a:t>
             </a:r>
           </a:p>
         </p:txBody>
@@ -4065,7 +4069,7 @@
                   <a:srgbClr val="2A2A2A"/>
                 </a:solidFill>
               </a:rPr>
-              <a:t>• PseCo's inference uses anchor boxes (point ± half_side) as prompts for SAM's box-refinement head.</a:t>
+              <a:t>• PseCo 추론은 anchor box(점 ± half_side)를 SAM의 box-refinement 헤드 프롬프트로 사용.</a:t>
             </a:r>
           </a:p>
           <a:p>
@@ -4076,29 +4080,29 @@
                   <a:srgbClr val="2A2A2A"/>
                 </a:solidFill>
               </a:rPr>
-              <a:t>• Upstream demo: anchor_size = 8 on 1024-padded input (implies ~8 px half-side, ~16 px full side).</a:t>
-            </a:r>
-          </a:p>
-          <a:p>
-            <a:pPr lvl="1"/>
-            <a:r>
-              <a:rPr sz="1500">
-                <a:solidFill>
-                  <a:srgbClr val="6B6B6B"/>
-                </a:solidFill>
-              </a:rPr>
-              <a:t>– Fine for FSC-147 where images are 384 longest side — objects are ~10–30 px.</a:t>
-            </a:r>
-          </a:p>
-          <a:p>
-            <a:pPr lvl="1"/>
-            <a:r>
-              <a:rPr sz="1500">
-                <a:solidFill>
-                  <a:srgbClr val="6B6B6B"/>
-                </a:solidFill>
-              </a:rPr>
-              <a:t>– Breaks on phone-taken orchard photos where objects span ~80–120 px in 1024 space.</a:t>
+              <a:t>• Upstream demo: 1024-padding 입력에서 anchor_size = 8 (약 8 px half-side, ~16 px full side).</a:t>
+            </a:r>
+          </a:p>
+          <a:p>
+            <a:pPr lvl="1"/>
+            <a:r>
+              <a:rPr sz="1500">
+                <a:solidFill>
+                  <a:srgbClr val="6B6B6B"/>
+                </a:solidFill>
+              </a:rPr>
+              <a:t>– FSC-147에는 적합 (이미지 긴 변 384 px, 객체 ~10–30 px).</a:t>
+            </a:r>
+          </a:p>
+          <a:p>
+            <a:pPr lvl="1"/>
+            <a:r>
+              <a:rPr sz="1500">
+                <a:solidFill>
+                  <a:srgbClr val="6B6B6B"/>
+                </a:solidFill>
+              </a:rPr>
+              <a:t>– 폰으로 찍은 과수원 사진(1024 공간에서 객체 ~80–120 px)에서는 작음.</a:t>
             </a:r>
           </a:p>
           <a:p>
@@ -4109,29 +4113,29 @@
                   <a:srgbClr val="2A2A2A"/>
                 </a:solidFill>
               </a:rPr>
-              <a:t>• Grid search over {4, 8, 12, 16, 24, 32}: apple detection monotone-improves with larger anchors up to ~24.</a:t>
-            </a:r>
-          </a:p>
-          <a:p>
-            <a:pPr lvl="1"/>
-            <a:r>
-              <a:rPr sz="1500">
-                <a:solidFill>
-                  <a:srgbClr val="6B6B6B"/>
-                </a:solidFill>
-              </a:rPr>
-              <a:t>– apple_1 (GT 48): 22 → 28 predictions as anchor goes 8 → 24.</a:t>
-            </a:r>
-          </a:p>
-          <a:p>
-            <a:pPr lvl="1"/>
-            <a:r>
-              <a:rPr sz="1500">
-                <a:solidFill>
-                  <a:srgbClr val="6B6B6B"/>
-                </a:solidFill>
-              </a:rPr>
-              <a:t>– Pears (smaller relative scale) unchanged.</a:t>
+              <a:t>• anchor_size ∈ {4, 8, 12, 16, 24, 32} 그리드 서치: 사과 검출 수가 ~24까지 단조 증가.</a:t>
+            </a:r>
+          </a:p>
+          <a:p>
+            <a:pPr lvl="1"/>
+            <a:r>
+              <a:rPr sz="1500">
+                <a:solidFill>
+                  <a:srgbClr val="6B6B6B"/>
+                </a:solidFill>
+              </a:rPr>
+              <a:t>– apple_1 (GT 48): anchor 8→24 변경 시 예측 22 → 28.</a:t>
+            </a:r>
+          </a:p>
+          <a:p>
+            <a:pPr lvl="1"/>
+            <a:r>
+              <a:rPr sz="1500">
+                <a:solidFill>
+                  <a:srgbClr val="6B6B6B"/>
+                </a:solidFill>
+              </a:rPr>
+              <a:t>– 배(상대적으로 작음)는 변화 없음.</a:t>
             </a:r>
           </a:p>
           <a:p>
@@ -4142,29 +4146,29 @@
                   <a:srgbClr val="2A2A2A"/>
                 </a:solidFill>
               </a:rPr>
-              <a:t>• Why SAM is scale-sensitive here:</a:t>
-            </a:r>
-          </a:p>
-          <a:p>
-            <a:pPr lvl="1"/>
-            <a:r>
-              <a:rPr sz="1500">
-                <a:solidFill>
-                  <a:srgbClr val="6B6B6B"/>
-                </a:solidFill>
-              </a:rPr>
-              <a:t>– SAM was trained to segment from prompts that are INSIDE the object. Small anchors around a correct point still lie inside apples, but the mask-decoder's best hypothesis matches the anchor's scale.</a:t>
-            </a:r>
-          </a:p>
-          <a:p>
-            <a:pPr lvl="1"/>
-            <a:r>
-              <a:rPr sz="1500">
-                <a:solidFill>
-                  <a:srgbClr val="6B6B6B"/>
-                </a:solidFill>
-              </a:rPr>
-              <a:t>– Research question: scale-adaptive anchor ensembles? Multi-scale voting?</a:t>
+              <a:t>• SAM이 스케일에 민감한 이유:</a:t>
+            </a:r>
+          </a:p>
+          <a:p>
+            <a:pPr lvl="1"/>
+            <a:r>
+              <a:rPr sz="1500">
+                <a:solidFill>
+                  <a:srgbClr val="6B6B6B"/>
+                </a:solidFill>
+              </a:rPr>
+              <a:t>– SAM은 객체 INSIDE 프롬프트에서 segment하도록 학습됨. 작은 anchor도 사과 내부에 있지만, 마스크 디코더의 best 가설이 anchor 스케일을 따라감.</a:t>
+            </a:r>
+          </a:p>
+          <a:p>
+            <a:pPr lvl="1"/>
+            <a:r>
+              <a:rPr sz="1500">
+                <a:solidFill>
+                  <a:srgbClr val="6B6B6B"/>
+                </a:solidFill>
+              </a:rPr>
+              <a:t>– 연구 질문: 스케일 적응형 anchor 앙상블? 다중 스케일 투표?</a:t>
             </a:r>
           </a:p>
         </p:txBody>
@@ -4215,7 +4219,7 @@
                   <a:srgbClr val="2E5F8A"/>
                 </a:solidFill>
               </a:rPr>
-              <a:t>Insight 6 — Prompt Engineering Can Replace Fine-tuning When Fine-tuning Would Break Alignment</a:t>
+              <a:t>인사이트 6 — 정렬을 깨뜨리는 파인튜닝보다 프롬프트 엔지니어링이 강할 수 있음</a:t>
             </a:r>
           </a:p>
         </p:txBody>
@@ -4249,7 +4253,7 @@
                   <a:srgbClr val="2A2A2A"/>
                 </a:solidFill>
               </a:rPr>
-              <a:t>• On orchard images, upstream MLP MAE by prompt:</a:t>
+              <a:t>• 과수원 이미지에서 upstream MLP의 프롬프트별 MAE:</a:t>
             </a:r>
           </a:p>
           <a:p>
@@ -4293,7 +4297,7 @@
                   <a:srgbClr val="2A2A2A"/>
                 </a:solidFill>
               </a:rPr>
-              <a:t>• A three-word prompt change saves ~30 MAE points on pears. No retraining required.</a:t>
+              <a:t>• 배에서 세 단어의 프롬프트 변경이 MAE 약 30을 줄임. 재학습 필요 없음.</a:t>
             </a:r>
           </a:p>
           <a:p>
@@ -4304,29 +4308,29 @@
                   <a:srgbClr val="2A2A2A"/>
                 </a:solidFill>
               </a:rPr>
-              <a:t>• Mechanism: CLIP's text encoder captures compositional semantics (fruit-class × environment).</a:t>
-            </a:r>
-          </a:p>
-          <a:p>
-            <a:pPr lvl="1"/>
-            <a:r>
-              <a:rPr sz="1500">
-                <a:solidFill>
-                  <a:srgbClr val="6B6B6B"/>
-                </a:solidFill>
-              </a:rPr>
-              <a:t>– "apple in paper bag" activates BOTH the apple cluster and the packaging context.</a:t>
-            </a:r>
-          </a:p>
-          <a:p>
-            <a:pPr lvl="1"/>
-            <a:r>
-              <a:rPr sz="1500">
-                <a:solidFill>
-                  <a:srgbClr val="6B6B6B"/>
-                </a:solidFill>
-              </a:rPr>
-              <a:t>– "apples" alone activates the apple cluster — less specific → overshoots on wide scenes.</a:t>
+              <a:t>• 메커니즘: CLIP 텍스트 인코더가 조합적 의미(과일 종류 × 포장 맥락)를 포착.</a:t>
+            </a:r>
+          </a:p>
+          <a:p>
+            <a:pPr lvl="1"/>
+            <a:r>
+              <a:rPr sz="1500">
+                <a:solidFill>
+                  <a:srgbClr val="6B6B6B"/>
+                </a:solidFill>
+              </a:rPr>
+              <a:t>– "apple in paper bag" — 사과 클러스터 + 포장 맥락을 동시 활성화.</a:t>
+            </a:r>
+          </a:p>
+          <a:p>
+            <a:pPr lvl="1"/>
+            <a:r>
+              <a:rPr sz="1500">
+                <a:solidFill>
+                  <a:srgbClr val="6B6B6B"/>
+                </a:solidFill>
+              </a:rPr>
+              <a:t>– "apples" 단독은 사과 클러스터만 활성화 — 덜 구체적 → 넓은 장면에서 과잉 검출.</a:t>
             </a:r>
           </a:p>
           <a:p>
@@ -4337,18 +4341,18 @@
                   <a:srgbClr val="2A2A2A"/>
                 </a:solidFill>
               </a:rPr>
-              <a:t>• Implication: for class-agnostic counting pipelines, prompt search should be the FIRST intervention, not fine-tuning.</a:t>
-            </a:r>
-          </a:p>
-          <a:p>
-            <a:pPr lvl="1"/>
-            <a:r>
-              <a:rPr sz="1500">
-                <a:solidFill>
-                  <a:srgbClr val="6B6B6B"/>
-                </a:solidFill>
-              </a:rPr>
-              <a:t>– Fine-tuning risks CLIP alignment loss; prompt search is free and reversible.</a:t>
+              <a:t>• 함의: 클래스 무관 카운팅 파이프라인에서는 파인튜닝이 아니라 프롬프트 서치를 FIRST 개입으로.</a:t>
+            </a:r>
+          </a:p>
+          <a:p>
+            <a:pPr lvl="1"/>
+            <a:r>
+              <a:rPr sz="1500">
+                <a:solidFill>
+                  <a:srgbClr val="6B6B6B"/>
+                </a:solidFill>
+              </a:rPr>
+              <a:t>– 파인튜닝은 CLIP 정렬 손실 위험. 프롬프트 서치는 공짜이고 가역적.</a:t>
             </a:r>
           </a:p>
         </p:txBody>
@@ -4409,7 +4413,7 @@
                   <a:srgbClr val="1F3B5C"/>
                 </a:solidFill>
               </a:rPr>
-              <a:t>Open Questions · Future Work</a:t>
+              <a:t>열린 질문 · 향후 연구</a:t>
             </a:r>
           </a:p>
         </p:txBody>
@@ -4460,7 +4464,7 @@
                   <a:srgbClr val="2E5F8A"/>
                 </a:solidFill>
               </a:rPr>
-              <a:t>What We Could Not Answer in This Sprint</a:t>
+              <a:t>이번 이터레이션에서 답하지 못한 질문</a:t>
             </a:r>
           </a:p>
         </p:txBody>
@@ -4493,7 +4497,7 @@
                   <a:srgbClr val="C2562D"/>
                 </a:solidFill>
               </a:rPr>
-              <a:t>Data-dependent</a:t>
+              <a:t>데이터 의존적</a:t>
             </a:r>
           </a:p>
           <a:p>
@@ -4504,7 +4508,7 @@
                   <a:srgbClr val="2A2A2A"/>
                 </a:solidFill>
               </a:rPr>
-              <a:t>• How well does our default pipeline work on actual protective-bag imagery?</a:t>
+              <a:t>• 봉지 과일 실제 이미지에서 우리 기본 파이프라인의 실제 성능은?</a:t>
             </a:r>
           </a:p>
           <a:p>
@@ -4515,7 +4519,7 @@
                   <a:srgbClr val="6B6B6B"/>
                 </a:solidFill>
               </a:rPr>
-              <a:t>– The captures we had were blank JPEGs (all pixels = 255).</a:t>
+              <a:t>– 우리가 받은 captures는 모두 흰 픽셀(255)로 비어 있었음.</a:t>
             </a:r>
           </a:p>
           <a:p>
@@ -4526,7 +4530,7 @@
                   <a:srgbClr val="2A2A2A"/>
                 </a:solidFill>
               </a:rPr>
-              <a:t>• Domain-specific labels: we have none. 50 hand-counted images would be enough for a proper MAE curve.</a:t>
+              <a:t>• 도메인 라벨 없음. 50장 정도 수동 카운팅하면 정상적 MAE 곡선 가능.</a:t>
             </a:r>
           </a:p>
           <a:p>
@@ -4537,7 +4541,7 @@
                   <a:srgbClr val="2A2A2A"/>
                 </a:solidFill>
               </a:rPr>
-              <a:t>• Is the remaining apple undercount (GT ~47, pred ~30) a SAM-scale problem or a CLIP-semantics problem?</a:t>
+              <a:t>• 남은 사과 undercount (GT ~47, pred ~30)는 SAM 스케일 문제인가, CLIP 의미 문제인가?</a:t>
             </a:r>
           </a:p>
           <a:p>
@@ -4548,7 +4552,7 @@
                   <a:srgbClr val="6B6B6B"/>
                 </a:solidFill>
               </a:rPr>
-              <a:t>– Needs multi-scale anchor ensemble ablation.</a:t>
+              <a:t>– 다중 스케일 anchor 앙상블 ablation 필요.</a:t>
             </a:r>
           </a:p>
         </p:txBody>
@@ -4581,7 +4585,7 @@
                   <a:srgbClr val="C2562D"/>
                 </a:solidFill>
               </a:rPr>
-              <a:t>Theory-dependent</a:t>
+              <a:t>이론 의존적</a:t>
             </a:r>
           </a:p>
           <a:p>
@@ -4592,7 +4596,7 @@
                   <a:srgbClr val="2A2A2A"/>
                 </a:solidFill>
               </a:rPr>
-              <a:t>• Can we preserve CLIP alignment during fine-tuning with a single auxiliary loss?</a:t>
+              <a:t>• 단일 보조 손실로 파인튜닝 중 CLIP 정렬을 유지할 수 있는가?</a:t>
             </a:r>
           </a:p>
           <a:p>
@@ -4603,7 +4607,7 @@
                   <a:srgbClr val="6B6B6B"/>
                 </a:solidFill>
               </a:rPr>
-              <a:t>– PseCo's `cls_loss2` is one candidate — an offline CLIP-region consistency term.</a:t>
+              <a:t>– PseCo의 `cls_loss2`는 후보 — 별도 배치에서 CLIP-검출 region에 대한 일관성 항.</a:t>
             </a:r>
           </a:p>
           <a:p>
@@ -4614,7 +4618,7 @@
                   <a:srgbClr val="6B6B6B"/>
                 </a:solidFill>
               </a:rPr>
-              <a:t>– Could a simpler text-prompt-discrimination loss work?</a:t>
+              <a:t>– 더 단순한 text-prompt-discrimination 손실로 대체 가능할까?</a:t>
             </a:r>
           </a:p>
           <a:p>
@@ -4625,7 +4629,7 @@
                   <a:srgbClr val="2A2A2A"/>
                 </a:solidFill>
               </a:rPr>
-              <a:t>• Scale-adaptive proposal generation — currently manual anchor tuning per domain.</a:t>
+              <a:t>• 스케일 적응형 proposal 생성 — 현재는 도메인별 수동 anchor 튜닝.</a:t>
             </a:r>
           </a:p>
           <a:p>
@@ -4636,7 +4640,7 @@
                   <a:srgbClr val="2A2A2A"/>
                 </a:solidFill>
               </a:rPr>
-              <a:t>• Is there a principled metric for "CLIP alignment retained after fine-tuning"?</a:t>
+              <a:t>• "파인튜닝 후에도 CLIP 정렬 유지"를 측정하는 원리적 지표는 무엇인가?</a:t>
             </a:r>
           </a:p>
         </p:txBody>
@@ -4687,7 +4691,7 @@
                   <a:srgbClr val="2E5F8A"/>
                 </a:solidFill>
               </a:rPr>
-              <a:t>Suggested Research Directions</a:t>
+              <a:t>권장 연구 방향</a:t>
             </a:r>
           </a:p>
         </p:txBody>
@@ -4721,40 +4725,40 @@
                   <a:srgbClr val="2A2A2A"/>
                 </a:solidFill>
               </a:rPr>
-              <a:t>• Direction A — Alignment-preserving fine-tuning.</a:t>
-            </a:r>
-          </a:p>
-          <a:p>
-            <a:pPr lvl="1"/>
-            <a:r>
-              <a:rPr sz="1500">
-                <a:solidFill>
-                  <a:srgbClr val="6B6B6B"/>
-                </a:solidFill>
-              </a:rPr>
-              <a:t>– Port PseCo's `cls_loss2` (CLIP-consistency on separate batches of CLIP-detected regions).</a:t>
-            </a:r>
-          </a:p>
-          <a:p>
-            <a:pPr lvl="1"/>
-            <a:r>
-              <a:rPr sz="1500">
-                <a:solidFill>
-                  <a:srgbClr val="6B6B6B"/>
-                </a:solidFill>
-              </a:rPr>
-              <a:t>– Evaluate against our Plan 3 trainer, which lost alignment.</a:t>
-            </a:r>
-          </a:p>
-          <a:p>
-            <a:pPr lvl="1"/>
-            <a:r>
-              <a:rPr sz="1500">
-                <a:solidFill>
-                  <a:srgbClr val="6B6B6B"/>
-                </a:solidFill>
-              </a:rPr>
-              <a:t>– Target: fine-tune on orchard data while keeping prompt-discrimination &gt; threshold.</a:t>
+              <a:t>• Direction A — 정렬 보존 파인튜닝.</a:t>
+            </a:r>
+          </a:p>
+          <a:p>
+            <a:pPr lvl="1"/>
+            <a:r>
+              <a:rPr sz="1500">
+                <a:solidFill>
+                  <a:srgbClr val="6B6B6B"/>
+                </a:solidFill>
+              </a:rPr>
+              <a:t>– PseCo의 `cls_loss2` (CLIP-검출 region에 대한 별도 배치 일관성 손실)을 우리 트레이너로 이식.</a:t>
+            </a:r>
+          </a:p>
+          <a:p>
+            <a:pPr lvl="1"/>
+            <a:r>
+              <a:rPr sz="1500">
+                <a:solidFill>
+                  <a:srgbClr val="6B6B6B"/>
+                </a:solidFill>
+              </a:rPr>
+              <a:t>– 정렬을 잃은 Plan 3 트레이너와 비교 평가.</a:t>
+            </a:r>
+          </a:p>
+          <a:p>
+            <a:pPr lvl="1"/>
+            <a:r>
+              <a:rPr sz="1500">
+                <a:solidFill>
+                  <a:srgbClr val="6B6B6B"/>
+                </a:solidFill>
+              </a:rPr>
+              <a:t>– 목표: 과수원 데이터 파인튜닝 중에도 prompt-discrimination을 임계 이상으로 유지.</a:t>
             </a:r>
           </a:p>
           <a:p>
@@ -4765,29 +4769,29 @@
                   <a:srgbClr val="2A2A2A"/>
                 </a:solidFill>
               </a:rPr>
-              <a:t>• Direction B — Scale-adaptive counting.</a:t>
-            </a:r>
-          </a:p>
-          <a:p>
-            <a:pPr lvl="1"/>
-            <a:r>
-              <a:rPr sz="1500">
-                <a:solidFill>
-                  <a:srgbClr val="6B6B6B"/>
-                </a:solidFill>
-              </a:rPr>
-              <a:t>– Multi-anchor ensemble: run SAM with anchors ∈ {4, 8, 16, 24, 32}, aggregate scores, NMS jointly.</a:t>
-            </a:r>
-          </a:p>
-          <a:p>
-            <a:pPr lvl="1"/>
-            <a:r>
-              <a:rPr sz="1500">
-                <a:solidFill>
-                  <a:srgbClr val="6B6B6B"/>
-                </a:solidFill>
-              </a:rPr>
-              <a:t>– Or learn a tiny anchor-size predictor from image statistics.</a:t>
+              <a:t>• Direction B — 스케일 적응형 카운팅.</a:t>
+            </a:r>
+          </a:p>
+          <a:p>
+            <a:pPr lvl="1"/>
+            <a:r>
+              <a:rPr sz="1500">
+                <a:solidFill>
+                  <a:srgbClr val="6B6B6B"/>
+                </a:solidFill>
+              </a:rPr>
+              <a:t>– 다중 anchor 앙상블: anchor ∈ {4, 8, 16, 24, 32} 병렬 실행 후 점수 통합 + 공동 NMS.</a:t>
+            </a:r>
+          </a:p>
+          <a:p>
+            <a:pPr lvl="1"/>
+            <a:r>
+              <a:rPr sz="1500">
+                <a:solidFill>
+                  <a:srgbClr val="6B6B6B"/>
+                </a:solidFill>
+              </a:rPr>
+              <a:t>– 혹은 이미지 통계로부터 anchor 크기를 예측하는 작은 모델 학습.</a:t>
             </a:r>
           </a:p>
           <a:p>
@@ -4798,29 +4802,29 @@
                   <a:srgbClr val="2A2A2A"/>
                 </a:solidFill>
               </a:rPr>
-              <a:t>• Direction C — Baseline-aware counting metrics.</a:t>
-            </a:r>
-          </a:p>
-          <a:p>
-            <a:pPr lvl="1"/>
-            <a:r>
-              <a:rPr sz="1500">
-                <a:solidFill>
-                  <a:srgbClr val="6B6B6B"/>
-                </a:solidFill>
-              </a:rPr>
-              <a:t>– Report MAE minus 'predict mean' and MAE minus 'predict zero' jointly.</a:t>
-            </a:r>
-          </a:p>
-          <a:p>
-            <a:pPr lvl="1"/>
-            <a:r>
-              <a:rPr sz="1500">
-                <a:solidFill>
-                  <a:srgbClr val="6B6B6B"/>
-                </a:solidFill>
-              </a:rPr>
-              <a:t>– Helps distinguish real learning from distribution memorization on skewed count datasets.</a:t>
+              <a:t>• Direction C — Baseline 인식 카운팅 지표.</a:t>
+            </a:r>
+          </a:p>
+          <a:p>
+            <a:pPr lvl="1"/>
+            <a:r>
+              <a:rPr sz="1500">
+                <a:solidFill>
+                  <a:srgbClr val="6B6B6B"/>
+                </a:solidFill>
+              </a:rPr>
+              <a:t>– MAE - predict-mean, MAE - predict-zero 두 값을 함께 리포트.</a:t>
+            </a:r>
+          </a:p>
+          <a:p>
+            <a:pPr lvl="1"/>
+            <a:r>
+              <a:rPr sz="1500">
+                <a:solidFill>
+                  <a:srgbClr val="6B6B6B"/>
+                </a:solidFill>
+              </a:rPr>
+              <a:t>– 왜곡된 카운트 분포에서 "실제 학습"과 "분포 암기"를 구분해 줌.</a:t>
             </a:r>
           </a:p>
           <a:p>
@@ -4831,29 +4835,29 @@
                   <a:srgbClr val="2A2A2A"/>
                 </a:solidFill>
               </a:rPr>
-              <a:t>• Direction D — Prompt optimization as a first-class step.</a:t>
-            </a:r>
-          </a:p>
-          <a:p>
-            <a:pPr lvl="1"/>
-            <a:r>
-              <a:rPr sz="1500">
-                <a:solidFill>
-                  <a:srgbClr val="6B6B6B"/>
-                </a:solidFill>
-              </a:rPr>
-              <a:t>– Systematic prompt search before any fine-tuning is considered.</a:t>
-            </a:r>
-          </a:p>
-          <a:p>
-            <a:pPr lvl="1"/>
-            <a:r>
-              <a:rPr sz="1500">
-                <a:solidFill>
-                  <a:srgbClr val="6B6B6B"/>
-                </a:solidFill>
-              </a:rPr>
-              <a:t>– A learned prompt-generator conditioned on image embedding could hybridize this.</a:t>
+              <a:t>• Direction D — 프롬프트 최적화를 일급 단계로.</a:t>
+            </a:r>
+          </a:p>
+          <a:p>
+            <a:pPr lvl="1"/>
+            <a:r>
+              <a:rPr sz="1500">
+                <a:solidFill>
+                  <a:srgbClr val="6B6B6B"/>
+                </a:solidFill>
+              </a:rPr>
+              <a:t>– 파인튜닝 고려 전에 체계적 프롬프트 서치를 수행.</a:t>
+            </a:r>
+          </a:p>
+          <a:p>
+            <a:pPr lvl="1"/>
+            <a:r>
+              <a:rPr sz="1500">
+                <a:solidFill>
+                  <a:srgbClr val="6B6B6B"/>
+                </a:solidFill>
+              </a:rPr>
+              <a:t>– 이미지 임베딩에 조건화된 학습형 프롬프트 생성기로 하이브리드화 가능.</a:t>
             </a:r>
           </a:p>
         </p:txBody>
@@ -4914,7 +4918,7 @@
                   <a:srgbClr val="1F3B5C"/>
                 </a:solidFill>
               </a:rPr>
-              <a:t>Problem · Architecture · Theory</a:t>
+              <a:t>문제 · 아키텍처 · 이론</a:t>
             </a:r>
           </a:p>
         </p:txBody>
@@ -4965,7 +4969,7 @@
                   <a:srgbClr val="2E5F8A"/>
                 </a:solidFill>
               </a:rPr>
-              <a:t>Engineering Takeaways (Non-Research but Worth Keeping)</a:t>
+              <a:t>향후 진행 계획</a:t>
             </a:r>
           </a:p>
         </p:txBody>
@@ -4999,7 +5003,40 @@
                   <a:srgbClr val="2A2A2A"/>
                 </a:solidFill>
               </a:rPr>
-              <a:t>• Invalidation-aware caches save hours: SAM features cached with `(ckpt_hash, image_size, dtype)` hash.</a:t>
+              <a:t>• Plan 5 (즉시 재개 조건부) — 봉지 과일 데이터 확보 + 기초 검증</a:t>
+            </a:r>
+          </a:p>
+          <a:p>
+            <a:pPr lvl="1"/>
+            <a:r>
+              <a:rPr sz="1500">
+                <a:solidFill>
+                  <a:srgbClr val="6B6B6B"/>
+                </a:solidFill>
+              </a:rPr>
+              <a:t>– 작업: 배포 카메라로 봉지 과일 10~30장 재촬영 (현재 샘플은 흰 픽셀로 결함).</a:t>
+            </a:r>
+          </a:p>
+          <a:p>
+            <a:pPr lvl="1"/>
+            <a:r>
+              <a:rPr sz="1500">
+                <a:solidFill>
+                  <a:srgbClr val="6B6B6B"/>
+                </a:solidFill>
+              </a:rPr>
+              <a:t>– 작업: 수동 라벨링 — 이미지당 총 개수 + 핵심 샘플은 점 좌표까지.</a:t>
+            </a:r>
+          </a:p>
+          <a:p>
+            <a:pPr lvl="1"/>
+            <a:r>
+              <a:rPr sz="1500">
+                <a:solidFill>
+                  <a:srgbClr val="6B6B6B"/>
+                </a:solidFill>
+              </a:rPr>
+              <a:t>– 검증: upstream MLP 기본 설정 + 기본/튜닝 프롬프트로 MAE 측정. Plan 4 범위 내 해결 가능 여부 판정.</a:t>
             </a:r>
           </a:p>
           <a:p>
@@ -5010,7 +5047,51 @@
                   <a:srgbClr val="2A2A2A"/>
                 </a:solidFill>
               </a:rPr>
-              <a:t>• Every ML pipeline should have a 'predict-0' reference run; otherwise you may celebrate dataset-mean imitation.</a:t>
+              <a:t>• Plan 6 (조건부) — 정렬 보존 파인튜닝(C3)</a:t>
+            </a:r>
+          </a:p>
+          <a:p>
+            <a:pPr lvl="1"/>
+            <a:r>
+              <a:rPr sz="1500">
+                <a:solidFill>
+                  <a:srgbClr val="6B6B6B"/>
+                </a:solidFill>
+              </a:rPr>
+              <a:t>– 진입 조건: Plan 5 검증에서 upstream MAE가 불충분 (예: MAE &gt; 10).</a:t>
+            </a:r>
+          </a:p>
+          <a:p>
+            <a:pPr lvl="1"/>
+            <a:r>
+              <a:rPr sz="1500">
+                <a:solidFill>
+                  <a:srgbClr val="6B6B6B"/>
+                </a:solidFill>
+              </a:rPr>
+              <a:t>– 작업: upstream `3_extract_proposals.py`의 pseudo-box 생성 이식.</a:t>
+            </a:r>
+          </a:p>
+          <a:p>
+            <a:pPr lvl="1"/>
+            <a:r>
+              <a:rPr sz="1500">
+                <a:solidFill>
+                  <a:srgbClr val="6B6B6B"/>
+                </a:solidFill>
+              </a:rPr>
+              <a:t>– 작업: `cls_loss2` (CLIP 일관성 손실) 로 듀얼 loss 학습 루프 구현.</a:t>
+            </a:r>
+          </a:p>
+          <a:p>
+            <a:pPr lvl="1"/>
+            <a:r>
+              <a:rPr sz="1500">
+                <a:solidFill>
+                  <a:srgbClr val="6B6B6B"/>
+                </a:solidFill>
+              </a:rPr>
+              <a:t>– 작업: 과수원 라벨로 점진적 파인튜닝 + prompt-discrimination 모니터링.</a:t>
             </a:r>
           </a:p>
           <a:p>
@@ -5021,40 +5102,73 @@
                   <a:srgbClr val="2A2A2A"/>
                 </a:solidFill>
               </a:rPr>
-              <a:t>• Save a config snapshot INSIDE every checkpoint. We had several "this ckpt no longer loads" moments.</a:t>
-            </a:r>
-          </a:p>
-          <a:p>
-            <a:pPr/>
-            <a:r>
-              <a:rPr sz="1800">
-                <a:solidFill>
-                  <a:srgbClr val="2A2A2A"/>
-                </a:solidFill>
-              </a:rPr>
-              <a:t>• Integration tests marked `slow` with `skipif(weights_missing)` are better than no tests — but they need to actually run in CI at least weekly.</a:t>
-            </a:r>
-          </a:p>
-          <a:p>
-            <a:pPr/>
-            <a:r>
-              <a:rPr sz="1800">
-                <a:solidFill>
-                  <a:srgbClr val="2A2A2A"/>
-                </a:solidFill>
-              </a:rPr>
-              <a:t>• When adopting an upstream repo as a submodule, write a 20-minute 'does `demo.ipynb` actually import cleanly' check before trusting the API surface.</a:t>
-            </a:r>
-          </a:p>
-          <a:p>
-            <a:pPr lvl="1"/>
-            <a:r>
-              <a:rPr sz="1500">
-                <a:solidFill>
-                  <a:srgbClr val="6B6B6B"/>
-                </a:solidFill>
-              </a:rPr>
-              <a:t>– Our `PseCoStage.prepare()` had an import of a non-existent module for three plans.</a:t>
+              <a:t>• Plan 7 (선택) — 원래 Plan 4 스펙의 미사용 아이템</a:t>
+            </a:r>
+          </a:p>
+          <a:p>
+            <a:pPr lvl="1"/>
+            <a:r>
+              <a:rPr sz="1500">
+                <a:solidFill>
+                  <a:srgbClr val="6B6B6B"/>
+                </a:solidFill>
+              </a:rPr>
+              <a:t>– Classifier (ResNet18) 학습 — PseCo만으로 부족한 경우 verify 단계 추가.</a:t>
+            </a:r>
+          </a:p>
+          <a:p>
+            <a:pPr lvl="1"/>
+            <a:r>
+              <a:rPr sz="1500">
+                <a:solidFill>
+                  <a:srgbClr val="6B6B6B"/>
+                </a:solidFill>
+              </a:rPr>
+              <a:t>– Super-Resolution 통합 — small crop에서의 classification 개선 여지.</a:t>
+            </a:r>
+          </a:p>
+          <a:p>
+            <a:pPr lvl="1"/>
+            <a:r>
+              <a:rPr sz="1500">
+                <a:solidFill>
+                  <a:srgbClr val="6B6B6B"/>
+                </a:solidFill>
+              </a:rPr>
+              <a:t>– 과수원 전용 UI / 결과 시각화 대시보드 (비즈니스 요구 시).</a:t>
+            </a:r>
+          </a:p>
+        </p:txBody>
+      </p:sp>
+      <p:sp>
+        <p:nvSpPr>
+          <p:cNvPr id="4" name="TextBox 3"/>
+          <p:cNvSpPr txBox="1"/>
+          <p:nvPr/>
+        </p:nvSpPr>
+        <p:spPr>
+          <a:xfrm>
+            <a:off x="640080" y="6400800"/>
+            <a:ext cx="10972800" cy="365760"/>
+          </a:xfrm>
+          <a:prstGeom prst="rect">
+            <a:avLst/>
+          </a:prstGeom>
+          <a:noFill/>
+        </p:spPr>
+        <p:txBody>
+          <a:bodyPr wrap="none">
+            <a:spAutoFit/>
+          </a:bodyPr>
+          <a:lstStyle/>
+          <a:p>
+            <a:r>
+              <a:rPr sz="1100" i="1">
+                <a:solidFill>
+                  <a:srgbClr val="6B6B6B"/>
+                </a:solidFill>
+              </a:rPr>
+              <a:t>Plan 5 시작 선결조건: 실제 봉지 과일 이미지 + 라벨. 그 이전까지는 Plan 4 기본이 프로덕션.</a:t>
             </a:r>
           </a:p>
         </p:txBody>
@@ -5105,7 +5219,743 @@
                   <a:srgbClr val="2E5F8A"/>
                 </a:solidFill>
               </a:rPr>
-              <a:t>References</a:t>
+              <a:t>예상 결과 (Target Metrics)</a:t>
+            </a:r>
+          </a:p>
+        </p:txBody>
+      </p:sp>
+      <p:graphicFrame>
+        <p:nvGraphicFramePr>
+          <p:cNvPr id="3" name="Table 2"/>
+          <p:cNvGraphicFramePr>
+            <a:graphicFrameLocks noGrp="1"/>
+          </p:cNvGraphicFramePr>
+          <p:nvPr/>
+        </p:nvGraphicFramePr>
+        <p:xfrm>
+          <a:off x="640080" y="1188720"/>
+          <a:ext cx="11795760" cy="3749039"/>
+        </p:xfrm>
+        <a:graphic>
+          <a:graphicData uri="http://schemas.openxmlformats.org/drawingml/2006/table">
+            <a:tbl>
+              <a:tblPr firstRow="1" bandRow="1">
+                <a:tableStyleId>{5C22544A-7EE6-4342-B048-85BDC9FD1C3A}</a:tableStyleId>
+              </a:tblPr>
+              <a:tblGrid>
+                <a:gridCol w="3017520"/>
+                <a:gridCol w="2743200"/>
+                <a:gridCol w="3017520"/>
+                <a:gridCol w="3017520"/>
+              </a:tblGrid>
+              <a:tr h="468629">
+                <a:tc>
+                  <a:txBody>
+                    <a:bodyPr/>
+                    <a:lstStyle/>
+                    <a:p>
+                      <a:r>
+                        <a:rPr sz="1400" b="1">
+                          <a:solidFill>
+                            <a:srgbClr val="FFFFFF"/>
+                          </a:solidFill>
+                        </a:rPr>
+                        <a:t>지표</a:t>
+                      </a:r>
+                    </a:p>
+                  </a:txBody>
+                  <a:tcPr>
+                    <a:solidFill>
+                      <a:srgbClr val="2E5F8A"/>
+                    </a:solidFill>
+                  </a:tcPr>
+                </a:tc>
+                <a:tc>
+                  <a:txBody>
+                    <a:bodyPr/>
+                    <a:lstStyle/>
+                    <a:p>
+                      <a:r>
+                        <a:rPr sz="1400" b="1">
+                          <a:solidFill>
+                            <a:srgbClr val="FFFFFF"/>
+                          </a:solidFill>
+                        </a:rPr>
+                        <a:t>현재 (Plan 4 기본)</a:t>
+                      </a:r>
+                    </a:p>
+                  </a:txBody>
+                  <a:tcPr>
+                    <a:solidFill>
+                      <a:srgbClr val="2E5F8A"/>
+                    </a:solidFill>
+                  </a:tcPr>
+                </a:tc>
+                <a:tc>
+                  <a:txBody>
+                    <a:bodyPr/>
+                    <a:lstStyle/>
+                    <a:p>
+                      <a:r>
+                        <a:rPr sz="1400" b="1">
+                          <a:solidFill>
+                            <a:srgbClr val="FFFFFF"/>
+                          </a:solidFill>
+                        </a:rPr>
+                        <a:t>Plan 5 목표</a:t>
+                      </a:r>
+                    </a:p>
+                  </a:txBody>
+                  <a:tcPr>
+                    <a:solidFill>
+                      <a:srgbClr val="2E5F8A"/>
+                    </a:solidFill>
+                  </a:tcPr>
+                </a:tc>
+                <a:tc>
+                  <a:txBody>
+                    <a:bodyPr/>
+                    <a:lstStyle/>
+                    <a:p>
+                      <a:r>
+                        <a:rPr sz="1400" b="1">
+                          <a:solidFill>
+                            <a:srgbClr val="FFFFFF"/>
+                          </a:solidFill>
+                        </a:rPr>
+                        <a:t>Plan 6 목표 (파인튜닝 후)</a:t>
+                      </a:r>
+                    </a:p>
+                  </a:txBody>
+                  <a:tcPr>
+                    <a:solidFill>
+                      <a:srgbClr val="2E5F8A"/>
+                    </a:solidFill>
+                  </a:tcPr>
+                </a:tc>
+              </a:tr>
+              <a:tr h="468629">
+                <a:tc>
+                  <a:txBody>
+                    <a:bodyPr/>
+                    <a:lstStyle/>
+                    <a:p>
+                      <a:r>
+                        <a:rPr sz="1200">
+                          <a:solidFill>
+                            <a:srgbClr val="2A2A2A"/>
+                          </a:solidFill>
+                        </a:rPr>
+                        <a:t>과수원 phone 이미지 MAE (4장)</a:t>
+                      </a:r>
+                    </a:p>
+                  </a:txBody>
+                  <a:tcPr/>
+                </a:tc>
+                <a:tc>
+                  <a:txBody>
+                    <a:bodyPr/>
+                    <a:lstStyle/>
+                    <a:p>
+                      <a:r>
+                        <a:rPr sz="1200">
+                          <a:solidFill>
+                            <a:srgbClr val="2A2A2A"/>
+                          </a:solidFill>
+                        </a:rPr>
+                        <a:t>11.75</a:t>
+                      </a:r>
+                    </a:p>
+                  </a:txBody>
+                  <a:tcPr/>
+                </a:tc>
+                <a:tc>
+                  <a:txBody>
+                    <a:bodyPr/>
+                    <a:lstStyle/>
+                    <a:p>
+                      <a:r>
+                        <a:rPr sz="1200">
+                          <a:solidFill>
+                            <a:srgbClr val="2A2A2A"/>
+                          </a:solidFill>
+                        </a:rPr>
+                        <a:t>≤ 10</a:t>
+                      </a:r>
+                    </a:p>
+                  </a:txBody>
+                  <a:tcPr/>
+                </a:tc>
+                <a:tc>
+                  <a:txBody>
+                    <a:bodyPr/>
+                    <a:lstStyle/>
+                    <a:p>
+                      <a:r>
+                        <a:rPr sz="1200">
+                          <a:solidFill>
+                            <a:srgbClr val="2A2A2A"/>
+                          </a:solidFill>
+                        </a:rPr>
+                        <a:t>≤ 5</a:t>
+                      </a:r>
+                    </a:p>
+                  </a:txBody>
+                  <a:tcPr/>
+                </a:tc>
+              </a:tr>
+              <a:tr h="468629">
+                <a:tc>
+                  <a:txBody>
+                    <a:bodyPr/>
+                    <a:lstStyle/>
+                    <a:p>
+                      <a:r>
+                        <a:rPr sz="1200">
+                          <a:solidFill>
+                            <a:srgbClr val="2A2A2A"/>
+                          </a:solidFill>
+                        </a:rPr>
+                        <a:t>사과 undercount (GT 46-48)</a:t>
+                      </a:r>
+                    </a:p>
+                  </a:txBody>
+                  <a:tcPr>
+                    <a:solidFill>
+                      <a:srgbClr val="F2F2F2"/>
+                    </a:solidFill>
+                  </a:tcPr>
+                </a:tc>
+                <a:tc>
+                  <a:txBody>
+                    <a:bodyPr/>
+                    <a:lstStyle/>
+                    <a:p>
+                      <a:r>
+                        <a:rPr sz="1200">
+                          <a:solidFill>
+                            <a:srgbClr val="2A2A2A"/>
+                          </a:solidFill>
+                        </a:rPr>
+                        <a:t>pred 28-30 (-35%)</a:t>
+                      </a:r>
+                    </a:p>
+                  </a:txBody>
+                  <a:tcPr>
+                    <a:solidFill>
+                      <a:srgbClr val="F2F2F2"/>
+                    </a:solidFill>
+                  </a:tcPr>
+                </a:tc>
+                <a:tc>
+                  <a:txBody>
+                    <a:bodyPr/>
+                    <a:lstStyle/>
+                    <a:p>
+                      <a:r>
+                        <a:rPr sz="1200">
+                          <a:solidFill>
+                            <a:srgbClr val="2A2A2A"/>
+                          </a:solidFill>
+                        </a:rPr>
+                        <a:t>pred 35+ (-25%)</a:t>
+                      </a:r>
+                    </a:p>
+                  </a:txBody>
+                  <a:tcPr>
+                    <a:solidFill>
+                      <a:srgbClr val="F2F2F2"/>
+                    </a:solidFill>
+                  </a:tcPr>
+                </a:tc>
+                <a:tc>
+                  <a:txBody>
+                    <a:bodyPr/>
+                    <a:lstStyle/>
+                    <a:p>
+                      <a:r>
+                        <a:rPr sz="1200">
+                          <a:solidFill>
+                            <a:srgbClr val="2A2A2A"/>
+                          </a:solidFill>
+                        </a:rPr>
+                        <a:t>pred 42+ (-10%)</a:t>
+                      </a:r>
+                    </a:p>
+                  </a:txBody>
+                  <a:tcPr>
+                    <a:solidFill>
+                      <a:srgbClr val="F2F2F2"/>
+                    </a:solidFill>
+                  </a:tcPr>
+                </a:tc>
+              </a:tr>
+              <a:tr h="468629">
+                <a:tc>
+                  <a:txBody>
+                    <a:bodyPr/>
+                    <a:lstStyle/>
+                    <a:p>
+                      <a:r>
+                        <a:rPr sz="1200">
+                          <a:solidFill>
+                            <a:srgbClr val="2A2A2A"/>
+                          </a:solidFill>
+                        </a:rPr>
+                        <a:t>배 MAE</a:t>
+                      </a:r>
+                    </a:p>
+                  </a:txBody>
+                  <a:tcPr/>
+                </a:tc>
+                <a:tc>
+                  <a:txBody>
+                    <a:bodyPr/>
+                    <a:lstStyle/>
+                    <a:p>
+                      <a:r>
+                        <a:rPr sz="1200">
+                          <a:solidFill>
+                            <a:srgbClr val="2A2A2A"/>
+                          </a:solidFill>
+                        </a:rPr>
+                        <a:t>3-8</a:t>
+                      </a:r>
+                    </a:p>
+                  </a:txBody>
+                  <a:tcPr/>
+                </a:tc>
+                <a:tc>
+                  <a:txBody>
+                    <a:bodyPr/>
+                    <a:lstStyle/>
+                    <a:p>
+                      <a:r>
+                        <a:rPr sz="1200">
+                          <a:solidFill>
+                            <a:srgbClr val="2A2A2A"/>
+                          </a:solidFill>
+                        </a:rPr>
+                        <a:t>&lt; 5 (유지)</a:t>
+                      </a:r>
+                    </a:p>
+                  </a:txBody>
+                  <a:tcPr/>
+                </a:tc>
+                <a:tc>
+                  <a:txBody>
+                    <a:bodyPr/>
+                    <a:lstStyle/>
+                    <a:p>
+                      <a:r>
+                        <a:rPr sz="1200">
+                          <a:solidFill>
+                            <a:srgbClr val="2A2A2A"/>
+                          </a:solidFill>
+                        </a:rPr>
+                        <a:t>&lt; 3</a:t>
+                      </a:r>
+                    </a:p>
+                  </a:txBody>
+                  <a:tcPr/>
+                </a:tc>
+              </a:tr>
+              <a:tr h="468629">
+                <a:tc>
+                  <a:txBody>
+                    <a:bodyPr/>
+                    <a:lstStyle/>
+                    <a:p>
+                      <a:r>
+                        <a:rPr sz="1200">
+                          <a:solidFill>
+                            <a:srgbClr val="2A2A2A"/>
+                          </a:solidFill>
+                        </a:rPr>
+                        <a:t>봉지 과일 MAE</a:t>
+                      </a:r>
+                    </a:p>
+                  </a:txBody>
+                  <a:tcPr>
+                    <a:solidFill>
+                      <a:srgbClr val="F2F2F2"/>
+                    </a:solidFill>
+                  </a:tcPr>
+                </a:tc>
+                <a:tc>
+                  <a:txBody>
+                    <a:bodyPr/>
+                    <a:lstStyle/>
+                    <a:p>
+                      <a:r>
+                        <a:rPr sz="1200">
+                          <a:solidFill>
+                            <a:srgbClr val="2A2A2A"/>
+                          </a:solidFill>
+                        </a:rPr>
+                        <a:t>측정 불가(데이터 없음)</a:t>
+                      </a:r>
+                    </a:p>
+                  </a:txBody>
+                  <a:tcPr>
+                    <a:solidFill>
+                      <a:srgbClr val="F2F2F2"/>
+                    </a:solidFill>
+                  </a:tcPr>
+                </a:tc>
+                <a:tc>
+                  <a:txBody>
+                    <a:bodyPr/>
+                    <a:lstStyle/>
+                    <a:p>
+                      <a:r>
+                        <a:rPr sz="1200">
+                          <a:solidFill>
+                            <a:srgbClr val="2A2A2A"/>
+                          </a:solidFill>
+                        </a:rPr>
+                        <a:t>≤ 15 (라벨 확보 후)</a:t>
+                      </a:r>
+                    </a:p>
+                  </a:txBody>
+                  <a:tcPr>
+                    <a:solidFill>
+                      <a:srgbClr val="F2F2F2"/>
+                    </a:solidFill>
+                  </a:tcPr>
+                </a:tc>
+                <a:tc>
+                  <a:txBody>
+                    <a:bodyPr/>
+                    <a:lstStyle/>
+                    <a:p>
+                      <a:r>
+                        <a:rPr sz="1200">
+                          <a:solidFill>
+                            <a:srgbClr val="2A2A2A"/>
+                          </a:solidFill>
+                        </a:rPr>
+                        <a:t>≤ 8</a:t>
+                      </a:r>
+                    </a:p>
+                  </a:txBody>
+                  <a:tcPr>
+                    <a:solidFill>
+                      <a:srgbClr val="F2F2F2"/>
+                    </a:solidFill>
+                  </a:tcPr>
+                </a:tc>
+              </a:tr>
+              <a:tr h="468629">
+                <a:tc>
+                  <a:txBody>
+                    <a:bodyPr/>
+                    <a:lstStyle/>
+                    <a:p>
+                      <a:r>
+                        <a:rPr sz="1200">
+                          <a:solidFill>
+                            <a:srgbClr val="2A2A2A"/>
+                          </a:solidFill>
+                        </a:rPr>
+                        <a:t>CLIP 프롬프트 감도</a:t>
+                      </a:r>
+                    </a:p>
+                  </a:txBody>
+                  <a:tcPr/>
+                </a:tc>
+                <a:tc>
+                  <a:txBody>
+                    <a:bodyPr/>
+                    <a:lstStyle/>
+                    <a:p>
+                      <a:r>
+                        <a:rPr sz="1200">
+                          <a:solidFill>
+                            <a:srgbClr val="2A2A2A"/>
+                          </a:solidFill>
+                        </a:rPr>
+                        <a:t>upstream 수준 유지</a:t>
+                      </a:r>
+                    </a:p>
+                  </a:txBody>
+                  <a:tcPr/>
+                </a:tc>
+                <a:tc>
+                  <a:txBody>
+                    <a:bodyPr/>
+                    <a:lstStyle/>
+                    <a:p>
+                      <a:r>
+                        <a:rPr sz="1200">
+                          <a:solidFill>
+                            <a:srgbClr val="2A2A2A"/>
+                          </a:solidFill>
+                        </a:rPr>
+                        <a:t>유지</a:t>
+                      </a:r>
+                    </a:p>
+                  </a:txBody>
+                  <a:tcPr/>
+                </a:tc>
+                <a:tc>
+                  <a:txBody>
+                    <a:bodyPr/>
+                    <a:lstStyle/>
+                    <a:p>
+                      <a:r>
+                        <a:rPr sz="1200">
+                          <a:solidFill>
+                            <a:srgbClr val="2A2A2A"/>
+                          </a:solidFill>
+                        </a:rPr>
+                        <a:t>정렬 보존 학습으로 유지</a:t>
+                      </a:r>
+                    </a:p>
+                  </a:txBody>
+                  <a:tcPr/>
+                </a:tc>
+              </a:tr>
+              <a:tr h="468629">
+                <a:tc>
+                  <a:txBody>
+                    <a:bodyPr/>
+                    <a:lstStyle/>
+                    <a:p>
+                      <a:r>
+                        <a:rPr sz="1200">
+                          <a:solidFill>
+                            <a:srgbClr val="2A2A2A"/>
+                          </a:solidFill>
+                        </a:rPr>
+                        <a:t>val/mae on FSC-147</a:t>
+                      </a:r>
+                    </a:p>
+                  </a:txBody>
+                  <a:tcPr>
+                    <a:solidFill>
+                      <a:srgbClr val="F2F2F2"/>
+                    </a:solidFill>
+                  </a:tcPr>
+                </a:tc>
+                <a:tc>
+                  <a:txBody>
+                    <a:bodyPr/>
+                    <a:lstStyle/>
+                    <a:p>
+                      <a:r>
+                        <a:rPr sz="1200">
+                          <a:solidFill>
+                            <a:srgbClr val="2A2A2A"/>
+                          </a:solidFill>
+                        </a:rPr>
+                        <a:t>파인튜닝 미적용</a:t>
+                      </a:r>
+                    </a:p>
+                  </a:txBody>
+                  <a:tcPr>
+                    <a:solidFill>
+                      <a:srgbClr val="F2F2F2"/>
+                    </a:solidFill>
+                  </a:tcPr>
+                </a:tc>
+                <a:tc>
+                  <a:txBody>
+                    <a:bodyPr/>
+                    <a:lstStyle/>
+                    <a:p>
+                      <a:r>
+                        <a:rPr sz="1200">
+                          <a:solidFill>
+                            <a:srgbClr val="2A2A2A"/>
+                          </a:solidFill>
+                        </a:rPr>
+                        <a:t>—</a:t>
+                      </a:r>
+                    </a:p>
+                  </a:txBody>
+                  <a:tcPr>
+                    <a:solidFill>
+                      <a:srgbClr val="F2F2F2"/>
+                    </a:solidFill>
+                  </a:tcPr>
+                </a:tc>
+                <a:tc>
+                  <a:txBody>
+                    <a:bodyPr/>
+                    <a:lstStyle/>
+                    <a:p>
+                      <a:r>
+                        <a:rPr sz="1200">
+                          <a:solidFill>
+                            <a:srgbClr val="2A2A2A"/>
+                          </a:solidFill>
+                        </a:rPr>
+                        <a:t>≤ 20 (upstream 수준)</a:t>
+                      </a:r>
+                    </a:p>
+                  </a:txBody>
+                  <a:tcPr>
+                    <a:solidFill>
+                      <a:srgbClr val="F2F2F2"/>
+                    </a:solidFill>
+                  </a:tcPr>
+                </a:tc>
+              </a:tr>
+              <a:tr h="468636">
+                <a:tc>
+                  <a:txBody>
+                    <a:bodyPr/>
+                    <a:lstStyle/>
+                    <a:p>
+                      <a:r>
+                        <a:rPr sz="1200">
+                          <a:solidFill>
+                            <a:srgbClr val="2A2A2A"/>
+                          </a:solidFill>
+                        </a:rPr>
+                        <a:t>추론 속도 (RTX 5070)</a:t>
+                      </a:r>
+                    </a:p>
+                  </a:txBody>
+                  <a:tcPr/>
+                </a:tc>
+                <a:tc>
+                  <a:txBody>
+                    <a:bodyPr/>
+                    <a:lstStyle/>
+                    <a:p>
+                      <a:r>
+                        <a:rPr sz="1200">
+                          <a:solidFill>
+                            <a:srgbClr val="2A2A2A"/>
+                          </a:solidFill>
+                        </a:rPr>
+                        <a:t>이미지당 ~2 초</a:t>
+                      </a:r>
+                    </a:p>
+                  </a:txBody>
+                  <a:tcPr/>
+                </a:tc>
+                <a:tc>
+                  <a:txBody>
+                    <a:bodyPr/>
+                    <a:lstStyle/>
+                    <a:p>
+                      <a:r>
+                        <a:rPr sz="1200">
+                          <a:solidFill>
+                            <a:srgbClr val="2A2A2A"/>
+                          </a:solidFill>
+                        </a:rPr>
+                        <a:t>유지</a:t>
+                      </a:r>
+                    </a:p>
+                  </a:txBody>
+                  <a:tcPr/>
+                </a:tc>
+                <a:tc>
+                  <a:txBody>
+                    <a:bodyPr/>
+                    <a:lstStyle/>
+                    <a:p>
+                      <a:r>
+                        <a:rPr sz="1200">
+                          <a:solidFill>
+                            <a:srgbClr val="2A2A2A"/>
+                          </a:solidFill>
+                        </a:rPr>
+                        <a:t>유지</a:t>
+                      </a:r>
+                    </a:p>
+                  </a:txBody>
+                  <a:tcPr/>
+                </a:tc>
+              </a:tr>
+            </a:tbl>
+          </a:graphicData>
+        </a:graphic>
+      </p:graphicFrame>
+      <p:sp>
+        <p:nvSpPr>
+          <p:cNvPr id="4" name="TextBox 3"/>
+          <p:cNvSpPr txBox="1"/>
+          <p:nvPr/>
+        </p:nvSpPr>
+        <p:spPr>
+          <a:xfrm>
+            <a:off x="640080" y="6400800"/>
+            <a:ext cx="10972800" cy="365760"/>
+          </a:xfrm>
+          <a:prstGeom prst="rect">
+            <a:avLst/>
+          </a:prstGeom>
+          <a:noFill/>
+        </p:spPr>
+        <p:txBody>
+          <a:bodyPr wrap="none">
+            <a:spAutoFit/>
+          </a:bodyPr>
+          <a:lstStyle/>
+          <a:p>
+            <a:r>
+              <a:rPr sz="1100" i="1">
+                <a:solidFill>
+                  <a:srgbClr val="6B6B6B"/>
+                </a:solidFill>
+              </a:rPr>
+              <a:t>모든 숫자는 현 데이터 분포 기반 추정치. 실제 결과는 확보한 봉지 이미지의 품질·다양성에 따라 변동.</a:t>
+            </a:r>
+          </a:p>
+        </p:txBody>
+      </p:sp>
+    </p:spTree>
+  </p:cSld>
+  <p:clrMapOvr>
+    <a:masterClrMapping/>
+  </p:clrMapOvr>
+</p:sld>
+</file>
+
+<file path=ppt/slides/slide22.xml><?xml version="1.0" encoding="utf-8"?>
+<p:sld xmlns:a="http://schemas.openxmlformats.org/drawingml/2006/main" xmlns:p="http://schemas.openxmlformats.org/presentationml/2006/main" xmlns:r="http://schemas.openxmlformats.org/officeDocument/2006/relationships">
+  <p:cSld>
+    <p:spTree>
+      <p:nvGrpSpPr>
+        <p:cNvPr id="1" name=""/>
+        <p:cNvGrpSpPr/>
+        <p:nvPr/>
+      </p:nvGrpSpPr>
+      <p:grpSpPr/>
+      <p:sp>
+        <p:nvSpPr>
+          <p:cNvPr id="2" name="TextBox 1"/>
+          <p:cNvSpPr txBox="1"/>
+          <p:nvPr/>
+        </p:nvSpPr>
+        <p:spPr>
+          <a:xfrm>
+            <a:off x="457200" y="274320"/>
+            <a:ext cx="11430000" cy="731520"/>
+          </a:xfrm>
+          <a:prstGeom prst="rect">
+            <a:avLst/>
+          </a:prstGeom>
+          <a:noFill/>
+        </p:spPr>
+        <p:txBody>
+          <a:bodyPr wrap="none">
+            <a:spAutoFit/>
+          </a:bodyPr>
+          <a:lstStyle/>
+          <a:p>
+            <a:r>
+              <a:rPr sz="2600" b="1">
+                <a:solidFill>
+                  <a:srgbClr val="2E5F8A"/>
+                </a:solidFill>
+              </a:rPr>
+              <a:t>진입 조건 및 타임라인 (개략)</a:t>
             </a:r>
           </a:p>
         </p:txBody>
@@ -5139,6 +5989,514 @@
                   <a:srgbClr val="2A2A2A"/>
                 </a:solidFill>
               </a:rPr>
+              <a:t>• Plan 5 진입 조건: 정상적으로 내용물이 있는 봉지 과일 이미지 최소 10장 + 총 개수 라벨.</a:t>
+            </a:r>
+          </a:p>
+          <a:p>
+            <a:pPr lvl="1"/>
+            <a:r>
+              <a:rPr sz="1500">
+                <a:solidFill>
+                  <a:srgbClr val="6B6B6B"/>
+                </a:solidFill>
+              </a:rPr>
+              <a:t>– 조건 충족 시 예상 소요: ~1일 (데이터 업로드 0.5시간 + 평가 스크립트 실행 0.5시간 + 결과 분석).</a:t>
+            </a:r>
+          </a:p>
+          <a:p>
+            <a:pPr/>
+            <a:r>
+              <a:rPr sz="1800">
+                <a:solidFill>
+                  <a:srgbClr val="2A2A2A"/>
+                </a:solidFill>
+              </a:rPr>
+              <a:t>• Plan 6 진입 조건: Plan 5 결과에서 upstream + 튜닝만으로 MAE 목표 미달.</a:t>
+            </a:r>
+          </a:p>
+          <a:p>
+            <a:pPr lvl="1"/>
+            <a:r>
+              <a:rPr sz="1500">
+                <a:solidFill>
+                  <a:srgbClr val="6B6B6B"/>
+                </a:solidFill>
+              </a:rPr>
+              <a:t>– `cls_loss2` 이식 + pseudo-box 생성 + 학습 루프 재작성: ~3~5일 예상.</a:t>
+            </a:r>
+          </a:p>
+          <a:p>
+            <a:pPr lvl="1"/>
+            <a:r>
+              <a:rPr sz="1500">
+                <a:solidFill>
+                  <a:srgbClr val="6B6B6B"/>
+                </a:solidFill>
+              </a:rPr>
+              <a:t>– 실제 파인튜닝 + 검증: 추가 1~2일 (RTX 5070 기준).</a:t>
+            </a:r>
+          </a:p>
+          <a:p>
+            <a:pPr/>
+            <a:r>
+              <a:rPr sz="1800">
+                <a:solidFill>
+                  <a:srgbClr val="2A2A2A"/>
+                </a:solidFill>
+              </a:rPr>
+              <a:t>• Plan 7 진입 조건: PseCo 단독으로 false positive(봉지 아닌 것 카운팅) 가 문제일 때만.</a:t>
+            </a:r>
+          </a:p>
+          <a:p>
+            <a:pPr lvl="1"/>
+            <a:r>
+              <a:rPr sz="1500">
+                <a:solidFill>
+                  <a:srgbClr val="6B6B6B"/>
+                </a:solidFill>
+              </a:rPr>
+              <a:t>– ResNet18 분류기 학습: 라벨된 "봉지 crop" 500장 이상 필요.</a:t>
+            </a:r>
+          </a:p>
+          <a:p>
+            <a:pPr/>
+            <a:r>
+              <a:rPr sz="1800">
+                <a:solidFill>
+                  <a:srgbClr val="2A2A2A"/>
+                </a:solidFill>
+              </a:rPr>
+              <a:t>• 전체 일정은 라벨링 속도에 가장 크게 의존. 수작업 라벨링 페이스에 따라 전체 기간 결정.</a:t>
+            </a:r>
+          </a:p>
+        </p:txBody>
+      </p:sp>
+    </p:spTree>
+  </p:cSld>
+  <p:clrMapOvr>
+    <a:masterClrMapping/>
+  </p:clrMapOvr>
+</p:sld>
+</file>
+
+<file path=ppt/slides/slide23.xml><?xml version="1.0" encoding="utf-8"?>
+<p:sld xmlns:a="http://schemas.openxmlformats.org/drawingml/2006/main" xmlns:p="http://schemas.openxmlformats.org/presentationml/2006/main" xmlns:r="http://schemas.openxmlformats.org/officeDocument/2006/relationships">
+  <p:cSld>
+    <p:spTree>
+      <p:nvGrpSpPr>
+        <p:cNvPr id="1" name=""/>
+        <p:cNvGrpSpPr/>
+        <p:nvPr/>
+      </p:nvGrpSpPr>
+      <p:grpSpPr/>
+      <p:sp>
+        <p:nvSpPr>
+          <p:cNvPr id="2" name="TextBox 1"/>
+          <p:cNvSpPr txBox="1"/>
+          <p:nvPr/>
+        </p:nvSpPr>
+        <p:spPr>
+          <a:xfrm>
+            <a:off x="457200" y="274320"/>
+            <a:ext cx="11430000" cy="731520"/>
+          </a:xfrm>
+          <a:prstGeom prst="rect">
+            <a:avLst/>
+          </a:prstGeom>
+          <a:noFill/>
+        </p:spPr>
+        <p:txBody>
+          <a:bodyPr wrap="none">
+            <a:spAutoFit/>
+          </a:bodyPr>
+          <a:lstStyle/>
+          <a:p>
+            <a:r>
+              <a:rPr sz="2600" b="1">
+                <a:solidFill>
+                  <a:srgbClr val="2E5F8A"/>
+                </a:solidFill>
+              </a:rPr>
+              <a:t>리스크 및 감지 지표 (학습 중 체크포인트)</a:t>
+            </a:r>
+          </a:p>
+        </p:txBody>
+      </p:sp>
+      <p:sp>
+        <p:nvSpPr>
+          <p:cNvPr id="3" name="TextBox 2"/>
+          <p:cNvSpPr txBox="1"/>
+          <p:nvPr/>
+        </p:nvSpPr>
+        <p:spPr>
+          <a:xfrm>
+            <a:off x="640080" y="1097280"/>
+            <a:ext cx="10972800" cy="5303520"/>
+          </a:xfrm>
+          <a:prstGeom prst="rect">
+            <a:avLst/>
+          </a:prstGeom>
+          <a:noFill/>
+        </p:spPr>
+        <p:txBody>
+          <a:bodyPr wrap="square">
+            <a:spAutoFit/>
+          </a:bodyPr>
+          <a:lstStyle/>
+          <a:p>
+            <a:pPr/>
+            <a:r>
+              <a:rPr sz="1800">
+                <a:solidFill>
+                  <a:srgbClr val="2A2A2A"/>
+                </a:solidFill>
+              </a:rPr>
+              <a:t>• 리스크 R1 — Plan 5에서 실제 봉지 이미지 품질이 낮음 (흐림, 원거리, 조명 불량).</a:t>
+            </a:r>
+          </a:p>
+          <a:p>
+            <a:pPr lvl="1"/>
+            <a:r>
+              <a:rPr sz="1500">
+                <a:solidFill>
+                  <a:srgbClr val="6B6B6B"/>
+                </a:solidFill>
+              </a:rPr>
+              <a:t>– 감지: 진단 툴(`counting diagnose`)의 blur/exposure 분포로 선제 확인.</a:t>
+            </a:r>
+          </a:p>
+          <a:p>
+            <a:pPr lvl="1"/>
+            <a:r>
+              <a:rPr sz="1500">
+                <a:solidFill>
+                  <a:srgbClr val="6B6B6B"/>
+                </a:solidFill>
+              </a:rPr>
+              <a:t>– 대응: 촬영 가이드라인 재정립 혹은 이미지 Deblur/SR 전처리 활성화.</a:t>
+            </a:r>
+          </a:p>
+          <a:p>
+            <a:pPr/>
+            <a:r>
+              <a:rPr sz="1800">
+                <a:solidFill>
+                  <a:srgbClr val="2A2A2A"/>
+                </a:solidFill>
+              </a:rPr>
+              <a:t>• 리스크 R2 — Plan 6 파인튜닝에서 CLIP 정렬을 다시 잃음 (Plan 3 재현).</a:t>
+            </a:r>
+          </a:p>
+          <a:p>
+            <a:pPr lvl="1"/>
+            <a:r>
+              <a:rPr sz="1500">
+                <a:solidFill>
+                  <a:srgbClr val="6B6B6B"/>
+                </a:solidFill>
+              </a:rPr>
+              <a:t>– 감지: 매 N iter마다 prompt-discrimination 점수 (fixed triplet set) 기록.</a:t>
+            </a:r>
+          </a:p>
+          <a:p>
+            <a:pPr lvl="1"/>
+            <a:r>
+              <a:rPr sz="1500">
+                <a:solidFill>
+                  <a:srgbClr val="6B6B6B"/>
+                </a:solidFill>
+              </a:rPr>
+              <a:t>– 대응: `cls_loss2` 가중치 상향 / early stopping 기준 강화.</a:t>
+            </a:r>
+          </a:p>
+          <a:p>
+            <a:pPr/>
+            <a:r>
+              <a:rPr sz="1800">
+                <a:solidFill>
+                  <a:srgbClr val="2A2A2A"/>
+                </a:solidFill>
+              </a:rPr>
+              <a:t>• 리스크 R3 — 사과 undercount가 SAM 스케일이 아닌 더 깊은 문제 (가림, 색상 유사성).</a:t>
+            </a:r>
+          </a:p>
+          <a:p>
+            <a:pPr lvl="1"/>
+            <a:r>
+              <a:rPr sz="1500">
+                <a:solidFill>
+                  <a:srgbClr val="6B6B6B"/>
+                </a:solidFill>
+              </a:rPr>
+              <a:t>– 감지: PointDecoder의 점 수 + IoU(pred_box, visible_apples) 시각화.</a:t>
+            </a:r>
+          </a:p>
+          <a:p>
+            <a:pPr lvl="1"/>
+            <a:r>
+              <a:rPr sz="1500">
+                <a:solidFill>
+                  <a:srgbClr val="6B6B6B"/>
+                </a:solidFill>
+              </a:rPr>
+              <a:t>– 대응: 데이터 증강 (rotation, partial occlusion), 혹은 upstream 대신 다른 proposal 생성 방식.</a:t>
+            </a:r>
+          </a:p>
+          <a:p>
+            <a:pPr/>
+            <a:r>
+              <a:rPr sz="1800">
+                <a:solidFill>
+                  <a:srgbClr val="2A2A2A"/>
+                </a:solidFill>
+              </a:rPr>
+              <a:t>• 리스크 R4 — GPU 경합 (사용자의 다른 학습과 동시 실행).</a:t>
+            </a:r>
+          </a:p>
+          <a:p>
+            <a:pPr lvl="1"/>
+            <a:r>
+              <a:rPr sz="1500">
+                <a:solidFill>
+                  <a:srgbClr val="6B6B6B"/>
+                </a:solidFill>
+              </a:rPr>
+              <a:t>– 감지: `nvidia-smi --query-gpu=memory.used`.</a:t>
+            </a:r>
+          </a:p>
+          <a:p>
+            <a:pPr lvl="1"/>
+            <a:r>
+              <a:rPr sz="1500">
+                <a:solidFill>
+                  <a:srgbClr val="6B6B6B"/>
+                </a:solidFill>
+              </a:rPr>
+              <a:t>– 대응: 학습을 순차 실행, 배치 사이즈 동적 조정.</a:t>
+            </a:r>
+          </a:p>
+        </p:txBody>
+      </p:sp>
+    </p:spTree>
+  </p:cSld>
+  <p:clrMapOvr>
+    <a:masterClrMapping/>
+  </p:clrMapOvr>
+</p:sld>
+</file>
+
+<file path=ppt/slides/slide24.xml><?xml version="1.0" encoding="utf-8"?>
+<p:sld xmlns:a="http://schemas.openxmlformats.org/drawingml/2006/main" xmlns:p="http://schemas.openxmlformats.org/presentationml/2006/main" xmlns:r="http://schemas.openxmlformats.org/officeDocument/2006/relationships">
+  <p:cSld>
+    <p:spTree>
+      <p:nvGrpSpPr>
+        <p:cNvPr id="1" name=""/>
+        <p:cNvGrpSpPr/>
+        <p:nvPr/>
+      </p:nvGrpSpPr>
+      <p:grpSpPr/>
+      <p:sp>
+        <p:nvSpPr>
+          <p:cNvPr id="2" name="TextBox 1"/>
+          <p:cNvSpPr txBox="1"/>
+          <p:nvPr/>
+        </p:nvSpPr>
+        <p:spPr>
+          <a:xfrm>
+            <a:off x="457200" y="274320"/>
+            <a:ext cx="11430000" cy="731520"/>
+          </a:xfrm>
+          <a:prstGeom prst="rect">
+            <a:avLst/>
+          </a:prstGeom>
+          <a:noFill/>
+        </p:spPr>
+        <p:txBody>
+          <a:bodyPr wrap="none">
+            <a:spAutoFit/>
+          </a:bodyPr>
+          <a:lstStyle/>
+          <a:p>
+            <a:r>
+              <a:rPr sz="2600" b="1">
+                <a:solidFill>
+                  <a:srgbClr val="2E5F8A"/>
+                </a:solidFill>
+              </a:rPr>
+              <a:t>엔지니어링 측면 교훈 (연구는 아니지만 남길 가치 있음)</a:t>
+            </a:r>
+          </a:p>
+        </p:txBody>
+      </p:sp>
+      <p:sp>
+        <p:nvSpPr>
+          <p:cNvPr id="3" name="TextBox 2"/>
+          <p:cNvSpPr txBox="1"/>
+          <p:nvPr/>
+        </p:nvSpPr>
+        <p:spPr>
+          <a:xfrm>
+            <a:off x="640080" y="1097280"/>
+            <a:ext cx="10972800" cy="5303520"/>
+          </a:xfrm>
+          <a:prstGeom prst="rect">
+            <a:avLst/>
+          </a:prstGeom>
+          <a:noFill/>
+        </p:spPr>
+        <p:txBody>
+          <a:bodyPr wrap="square">
+            <a:spAutoFit/>
+          </a:bodyPr>
+          <a:lstStyle/>
+          <a:p>
+            <a:pPr/>
+            <a:r>
+              <a:rPr sz="1800">
+                <a:solidFill>
+                  <a:srgbClr val="2A2A2A"/>
+                </a:solidFill>
+              </a:rPr>
+              <a:t>• 캐시의 무효화 인식 설계는 시간을 크게 절약함. SAM 피처는 `(ckpt 해시, 이미지 크기, dtype)` 해시로 저장.</a:t>
+            </a:r>
+          </a:p>
+          <a:p>
+            <a:pPr/>
+            <a:r>
+              <a:rPr sz="1800">
+                <a:solidFill>
+                  <a:srgbClr val="2A2A2A"/>
+                </a:solidFill>
+              </a:rPr>
+              <a:t>• 모든 ML 파이프라인에 'predict-0' 참조 런을 함께 돌려야 함. 안 그러면 데이터셋 평균 모사에 속아 축하할 수 있음.</a:t>
+            </a:r>
+          </a:p>
+          <a:p>
+            <a:pPr/>
+            <a:r>
+              <a:rPr sz="1800">
+                <a:solidFill>
+                  <a:srgbClr val="2A2A2A"/>
+                </a:solidFill>
+              </a:rPr>
+              <a:t>• 모든 체크포인트 안에 설정 스냅샷을 같이 저장할 것. "이 ckpt가 더 이상 로드 안 됨" 순간이 몇 번 있었음.</a:t>
+            </a:r>
+          </a:p>
+          <a:p>
+            <a:pPr/>
+            <a:r>
+              <a:rPr sz="1800">
+                <a:solidFill>
+                  <a:srgbClr val="2A2A2A"/>
+                </a:solidFill>
+              </a:rPr>
+              <a:t>• `slow` 마커 + `skipif(가중치 없음)` 붙은 통합 테스트는 없는 것보단 낫지만 주기적으로 실제로 돌려야 함.</a:t>
+            </a:r>
+          </a:p>
+          <a:p>
+            <a:pPr/>
+            <a:r>
+              <a:rPr sz="1800">
+                <a:solidFill>
+                  <a:srgbClr val="2A2A2A"/>
+                </a:solidFill>
+              </a:rPr>
+              <a:t>• Upstream 레포를 submodule로 받을 땐 "demo.ipynb가 실제로 깨끗이 import되는가"를 20분 안에 점검하고 API surface를 믿을지 결정.</a:t>
+            </a:r>
+          </a:p>
+          <a:p>
+            <a:pPr lvl="1"/>
+            <a:r>
+              <a:rPr sz="1500">
+                <a:solidFill>
+                  <a:srgbClr val="6B6B6B"/>
+                </a:solidFill>
+              </a:rPr>
+              <a:t>– 우리 `PseCoStage.prepare()`는 세 Plan 동안 존재하지 않는 모듈을 import하고 있었음.</a:t>
+            </a:r>
+          </a:p>
+        </p:txBody>
+      </p:sp>
+    </p:spTree>
+  </p:cSld>
+  <p:clrMapOvr>
+    <a:masterClrMapping/>
+  </p:clrMapOvr>
+</p:sld>
+</file>
+
+<file path=ppt/slides/slide25.xml><?xml version="1.0" encoding="utf-8"?>
+<p:sld xmlns:a="http://schemas.openxmlformats.org/drawingml/2006/main" xmlns:p="http://schemas.openxmlformats.org/presentationml/2006/main" xmlns:r="http://schemas.openxmlformats.org/officeDocument/2006/relationships">
+  <p:cSld>
+    <p:spTree>
+      <p:nvGrpSpPr>
+        <p:cNvPr id="1" name=""/>
+        <p:cNvGrpSpPr/>
+        <p:nvPr/>
+      </p:nvGrpSpPr>
+      <p:grpSpPr/>
+      <p:sp>
+        <p:nvSpPr>
+          <p:cNvPr id="2" name="TextBox 1"/>
+          <p:cNvSpPr txBox="1"/>
+          <p:nvPr/>
+        </p:nvSpPr>
+        <p:spPr>
+          <a:xfrm>
+            <a:off x="457200" y="274320"/>
+            <a:ext cx="11430000" cy="731520"/>
+          </a:xfrm>
+          <a:prstGeom prst="rect">
+            <a:avLst/>
+          </a:prstGeom>
+          <a:noFill/>
+        </p:spPr>
+        <p:txBody>
+          <a:bodyPr wrap="none">
+            <a:spAutoFit/>
+          </a:bodyPr>
+          <a:lstStyle/>
+          <a:p>
+            <a:r>
+              <a:rPr sz="2600" b="1">
+                <a:solidFill>
+                  <a:srgbClr val="2E5F8A"/>
+                </a:solidFill>
+              </a:rPr>
+              <a:t>참고문헌</a:t>
+            </a:r>
+          </a:p>
+        </p:txBody>
+      </p:sp>
+      <p:sp>
+        <p:nvSpPr>
+          <p:cNvPr id="3" name="TextBox 2"/>
+          <p:cNvSpPr txBox="1"/>
+          <p:nvPr/>
+        </p:nvSpPr>
+        <p:spPr>
+          <a:xfrm>
+            <a:off x="640080" y="1097280"/>
+            <a:ext cx="10972800" cy="5303520"/>
+          </a:xfrm>
+          <a:prstGeom prst="rect">
+            <a:avLst/>
+          </a:prstGeom>
+          <a:noFill/>
+        </p:spPr>
+        <p:txBody>
+          <a:bodyPr wrap="square">
+            <a:spAutoFit/>
+          </a:bodyPr>
+          <a:lstStyle/>
+          <a:p>
+            <a:pPr/>
+            <a:r>
+              <a:rPr sz="1800">
+                <a:solidFill>
+                  <a:srgbClr val="2A2A2A"/>
+                </a:solidFill>
+              </a:rPr>
               <a:t>• PseCo — Huang et al., "Point, Segment, and Count: A Generalized Framework for Object Counting", ICLR 2024. github.com/Hzzone/PseCo</a:t>
             </a:r>
           </a:p>
@@ -5194,29 +6552,29 @@
                   <a:srgbClr val="2A2A2A"/>
                 </a:solidFill>
               </a:rPr>
-              <a:t>• This project — github.com/YBNML/fruit-counting</a:t>
-            </a:r>
-          </a:p>
-          <a:p>
-            <a:pPr lvl="1"/>
-            <a:r>
-              <a:rPr sz="1500">
-                <a:solidFill>
-                  <a:srgbClr val="6B6B6B"/>
-                </a:solidFill>
-              </a:rPr>
-              <a:t>– Specs under docs/superpowers/specs/</a:t>
-            </a:r>
-          </a:p>
-          <a:p>
-            <a:pPr lvl="1"/>
-            <a:r>
-              <a:rPr sz="1500">
-                <a:solidFill>
-                  <a:srgbClr val="6B6B6B"/>
-                </a:solidFill>
-              </a:rPr>
-              <a:t>– Per-plan implementation logs under docs/superpowers/plans/</a:t>
+              <a:t>• 본 프로젝트 — github.com/YBNML/fruit-counting</a:t>
+            </a:r>
+          </a:p>
+          <a:p>
+            <a:pPr lvl="1"/>
+            <a:r>
+              <a:rPr sz="1500">
+                <a:solidFill>
+                  <a:srgbClr val="6B6B6B"/>
+                </a:solidFill>
+              </a:rPr>
+              <a:t>– 스펙: docs/superpowers/specs/</a:t>
+            </a:r>
+          </a:p>
+          <a:p>
+            <a:pPr lvl="1"/>
+            <a:r>
+              <a:rPr sz="1500">
+                <a:solidFill>
+                  <a:srgbClr val="6B6B6B"/>
+                </a:solidFill>
+              </a:rPr>
+              <a:t>– Plan별 구현 기록: docs/superpowers/plans/</a:t>
             </a:r>
           </a:p>
         </p:txBody>
@@ -5267,7 +6625,7 @@
                   <a:srgbClr val="2E5F8A"/>
                 </a:solidFill>
               </a:rPr>
-              <a:t>The Problem</a:t>
+              <a:t>문제 정의</a:t>
             </a:r>
           </a:p>
         </p:txBody>
@@ -5301,7 +6659,7 @@
                   <a:srgbClr val="2A2A2A"/>
                 </a:solidFill>
               </a:rPr>
-              <a:t>• Goal: count protective-bagged fruits in orchard photos from a deploy camera.</a:t>
+              <a:t>• 목표: 배포 카메라로 촬영한 과수원 이미지에서 보호 봉지 씌운 과일의 개수를 셈.</a:t>
             </a:r>
           </a:p>
           <a:p>
@@ -5312,29 +6670,29 @@
                   <a:srgbClr val="2A2A2A"/>
                 </a:solidFill>
               </a:rPr>
-              <a:t>• Original code path: 5-stage pipeline (Deblur → PseCo → Super-Resolution → Classifier → Defect).</a:t>
-            </a:r>
-          </a:p>
-          <a:p>
-            <a:pPr lvl="1"/>
-            <a:r>
-              <a:rPr sz="1500">
-                <a:solidFill>
-                  <a:srgbClr val="6B6B6B"/>
-                </a:solidFill>
-              </a:rPr>
-              <a:t>– Each stage was a thin wrapper around an external model — inference-only.</a:t>
-            </a:r>
-          </a:p>
-          <a:p>
-            <a:pPr lvl="1"/>
-            <a:r>
-              <a:rPr sz="1500">
-                <a:solidFill>
-                  <a:srgbClr val="6B6B6B"/>
-                </a:solidFill>
-              </a:rPr>
-              <a:t>– No training code, no labeled orchard data, no systematic evaluation.</a:t>
+              <a:t>• 원본 파이프라인: 5단계 구성 (Deblur → PseCo → Super-Resolution → Classifier → Defect).</a:t>
+            </a:r>
+          </a:p>
+          <a:p>
+            <a:pPr lvl="1"/>
+            <a:r>
+              <a:rPr sz="1500">
+                <a:solidFill>
+                  <a:srgbClr val="6B6B6B"/>
+                </a:solidFill>
+              </a:rPr>
+              <a:t>– 각 단계는 외부 모델의 얇은 래퍼였고, 추론 전용 — 학습 코드 없음.</a:t>
+            </a:r>
+          </a:p>
+          <a:p>
+            <a:pPr lvl="1"/>
+            <a:r>
+              <a:rPr sz="1500">
+                <a:solidFill>
+                  <a:srgbClr val="6B6B6B"/>
+                </a:solidFill>
+              </a:rPr>
+              <a:t>– 자체 과수원 라벨 없음, 체계적 평가 없음.</a:t>
             </a:r>
           </a:p>
           <a:p>
@@ -5345,7 +6703,7 @@
                   <a:srgbClr val="2A2A2A"/>
                 </a:solidFill>
               </a:rPr>
-              <a:t>• Our task: redesign + add training + validate on real orchard imagery.</a:t>
+              <a:t>• 우리 과제: 전면 재설계 + 학습 코드 추가 + 실제 과수원 이미지로 검증.</a:t>
             </a:r>
           </a:p>
           <a:p>
@@ -5356,7 +6714,7 @@
                   <a:srgbClr val="2A2A2A"/>
                 </a:solidFill>
               </a:rPr>
-              <a:t>• Core research question: can an open-world counting model be domain-adapted without sacrificing generality?</a:t>
+              <a:t>• 연구 질문: 오픈월드 카운팅 모델을 일반성을 잃지 않고 도메인에 적응시킬 수 있는가?</a:t>
             </a:r>
           </a:p>
         </p:txBody>
@@ -5389,7 +6747,7 @@
                   <a:srgbClr val="6B6B6B"/>
                 </a:solidFill>
               </a:rPr>
-              <a:t>Spec: docs/superpowers/specs/2026-04-19-fruit-counting-redesign-design.md</a:t>
+              <a:t>스펙: docs/superpowers/specs/2026-04-19-fruit-counting-redesign-design.md</a:t>
             </a:r>
           </a:p>
         </p:txBody>
@@ -5440,7 +6798,7 @@
                   <a:srgbClr val="2E5F8A"/>
                 </a:solidFill>
               </a:rPr>
-              <a:t>Theoretical Components (1/3) — SAM (Segment Anything Model)</a:t>
+              <a:t>이론적 구성 요소 (1/3) — SAM (Segment Anything Model)</a:t>
             </a:r>
           </a:p>
         </p:txBody>
@@ -5474,40 +6832,40 @@
                   <a:srgbClr val="2A2A2A"/>
                 </a:solidFill>
               </a:rPr>
-              <a:t>• Meta AI, 2023. Foundation model for class-agnostic segmentation.</a:t>
-            </a:r>
-          </a:p>
-          <a:p>
-            <a:pPr lvl="1"/>
-            <a:r>
-              <a:rPr sz="1500">
-                <a:solidFill>
-                  <a:srgbClr val="6B6B6B"/>
-                </a:solidFill>
-              </a:rPr>
-              <a:t>– ViT-H image encoder: 1024×1024 input → (256, 64, 64) feature map.</a:t>
-            </a:r>
-          </a:p>
-          <a:p>
-            <a:pPr lvl="1"/>
-            <a:r>
-              <a:rPr sz="1500">
-                <a:solidFill>
-                  <a:srgbClr val="6B6B6B"/>
-                </a:solidFill>
-              </a:rPr>
-              <a:t>– Promptable mask decoder: accepts points / boxes / text as prompts.</a:t>
-            </a:r>
-          </a:p>
-          <a:p>
-            <a:pPr lvl="1"/>
-            <a:r>
-              <a:rPr sz="1500">
-                <a:solidFill>
-                  <a:srgbClr val="6B6B6B"/>
-                </a:solidFill>
-              </a:rPr>
-              <a:t>– Trained on 1B+ masks (SA-1B). Strong generalization to unseen domains.</a:t>
+              <a:t>• Meta AI, 2023 — 클래스 무관 세그멘테이션 파운데이션 모델.</a:t>
+            </a:r>
+          </a:p>
+          <a:p>
+            <a:pPr lvl="1"/>
+            <a:r>
+              <a:rPr sz="1500">
+                <a:solidFill>
+                  <a:srgbClr val="6B6B6B"/>
+                </a:solidFill>
+              </a:rPr>
+              <a:t>– ViT-H 이미지 인코더: 1024×1024 입력 → (256, 64, 64) 피처 맵.</a:t>
+            </a:r>
+          </a:p>
+          <a:p>
+            <a:pPr lvl="1"/>
+            <a:r>
+              <a:rPr sz="1500">
+                <a:solidFill>
+                  <a:srgbClr val="6B6B6B"/>
+                </a:solidFill>
+              </a:rPr>
+              <a:t>– 프롬프트 기반 마스크 디코더: 점 / 박스 / 텍스트 프롬프트 수용.</a:t>
+            </a:r>
+          </a:p>
+          <a:p>
+            <a:pPr lvl="1"/>
+            <a:r>
+              <a:rPr sz="1500">
+                <a:solidFill>
+                  <a:srgbClr val="6B6B6B"/>
+                </a:solidFill>
+              </a:rPr>
+              <a:t>– 10억 개 이상 마스크(SA-1B)로 학습 — 미지 도메인에서도 강한 일반화.</a:t>
             </a:r>
           </a:p>
           <a:p>
@@ -5518,29 +6876,29 @@
                   <a:srgbClr val="2A2A2A"/>
                 </a:solidFill>
               </a:rPr>
-              <a:t>• For counting: SAM provides object proposals given a candidate point.</a:t>
-            </a:r>
-          </a:p>
-          <a:p>
-            <a:pPr lvl="1"/>
-            <a:r>
-              <a:rPr sz="1500">
-                <a:solidFill>
-                  <a:srgbClr val="6B6B6B"/>
-                </a:solidFill>
-              </a:rPr>
-              <a:t>– `forward_sam_with_embeddings(features, points=...)` returns k=5 plausible masks per point.</a:t>
-            </a:r>
-          </a:p>
-          <a:p>
-            <a:pPr lvl="1"/>
-            <a:r>
-              <a:rPr sz="1500">
-                <a:solidFill>
-                  <a:srgbClr val="6B6B6B"/>
-                </a:solidFill>
-              </a:rPr>
-              <a:t>– Anchor boxes (point ± half_side) refine the mask hypotheses.</a:t>
+              <a:t>• 카운팅에서의 역할: 후보 점이 주어지면 SAM이 해당 객체의 제안(proposal)을 생성.</a:t>
+            </a:r>
+          </a:p>
+          <a:p>
+            <a:pPr lvl="1"/>
+            <a:r>
+              <a:rPr sz="1500">
+                <a:solidFill>
+                  <a:srgbClr val="6B6B6B"/>
+                </a:solidFill>
+              </a:rPr>
+              <a:t>– `forward_sam_with_embeddings(features, points=...)` — 점당 k=5개의 가능한 마스크 반환.</a:t>
+            </a:r>
+          </a:p>
+          <a:p>
+            <a:pPr lvl="1"/>
+            <a:r>
+              <a:rPr sz="1500">
+                <a:solidFill>
+                  <a:srgbClr val="6B6B6B"/>
+                </a:solidFill>
+              </a:rPr>
+              <a:t>– anchor box(점 ± half_side)로 마스크 가설을 정제.</a:t>
             </a:r>
           </a:p>
           <a:p>
@@ -5551,7 +6909,7 @@
                   <a:srgbClr val="2A2A2A"/>
                 </a:solidFill>
               </a:rPr>
-              <a:t>• Key property: SAM doesn't know WHAT an object is — only where an object-like blob is.</a:t>
+              <a:t>• 핵심 성질: SAM은 "그것이 무엇인지"는 모르고, "객체스러운 덩어리"의 위치만 안다.</a:t>
             </a:r>
           </a:p>
         </p:txBody>
@@ -5602,7 +6960,7 @@
                   <a:srgbClr val="2E5F8A"/>
                 </a:solidFill>
               </a:rPr>
-              <a:t>Theoretical Components (2/3) — CLIP Text Alignment</a:t>
+              <a:t>이론적 구성 요소 (2/3) — CLIP 텍스트 정렬</a:t>
             </a:r>
           </a:p>
         </p:txBody>
@@ -5636,40 +6994,40 @@
                   <a:srgbClr val="2A2A2A"/>
                 </a:solidFill>
               </a:rPr>
-              <a:t>• OpenAI, 2021. Image encoder + text encoder jointly trained on 400M (image, caption) pairs.</a:t>
-            </a:r>
-          </a:p>
-          <a:p>
-            <a:pPr lvl="1"/>
-            <a:r>
-              <a:rPr sz="1500">
-                <a:solidFill>
-                  <a:srgbClr val="6B6B6B"/>
-                </a:solidFill>
-              </a:rPr>
-              <a:t>– Text encoder maps class name → 512-dim embedding (for ViT-B/32 backbone).</a:t>
-            </a:r>
-          </a:p>
-          <a:p>
-            <a:pPr lvl="1"/>
-            <a:r>
-              <a:rPr sz="1500">
-                <a:solidFill>
-                  <a:srgbClr val="6B6B6B"/>
-                </a:solidFill>
-              </a:rPr>
-              <a:t>– Image encoder maps crops to the same 512-dim space.</a:t>
-            </a:r>
-          </a:p>
-          <a:p>
-            <a:pPr lvl="1"/>
-            <a:r>
-              <a:rPr sz="1500">
-                <a:solidFill>
-                  <a:srgbClr val="6B6B6B"/>
-                </a:solidFill>
-              </a:rPr>
-              <a:t>– Zero-shot classification via cosine similarity in shared space.</a:t>
+              <a:t>• OpenAI, 2021 — 4억 (이미지, 캡션) 페어로 이미지·텍스트 인코더를 공동 학습.</a:t>
+            </a:r>
+          </a:p>
+          <a:p>
+            <a:pPr lvl="1"/>
+            <a:r>
+              <a:rPr sz="1500">
+                <a:solidFill>
+                  <a:srgbClr val="6B6B6B"/>
+                </a:solidFill>
+              </a:rPr>
+              <a:t>– 텍스트 인코더: 클래스 이름 → 512-d 임베딩 (ViT-B/32 백본 기준).</a:t>
+            </a:r>
+          </a:p>
+          <a:p>
+            <a:pPr lvl="1"/>
+            <a:r>
+              <a:rPr sz="1500">
+                <a:solidFill>
+                  <a:srgbClr val="6B6B6B"/>
+                </a:solidFill>
+              </a:rPr>
+              <a:t>– 이미지 인코더: 크롭을 동일한 512-d 공간에 매핑.</a:t>
+            </a:r>
+          </a:p>
+          <a:p>
+            <a:pPr lvl="1"/>
+            <a:r>
+              <a:rPr sz="1500">
+                <a:solidFill>
+                  <a:srgbClr val="6B6B6B"/>
+                </a:solidFill>
+              </a:rPr>
+              <a:t>– 공유 공간에서의 코사인 유사도로 zero-shot 분류.</a:t>
             </a:r>
           </a:p>
           <a:p>
@@ -5680,18 +7038,18 @@
                   <a:srgbClr val="2A2A2A"/>
                 </a:solidFill>
               </a:rPr>
-              <a:t>• In PseCo: the ROIHeadMLP's 512-dim output is compared against CLIP text features as the classifier.</a:t>
-            </a:r>
-          </a:p>
-          <a:p>
-            <a:pPr lvl="1"/>
-            <a:r>
-              <a:rPr sz="1500">
-                <a:solidFill>
-                  <a:srgbClr val="6B6B6B"/>
-                </a:solidFill>
-              </a:rPr>
-              <a:t>– dot(ROI_feature, text_feature) → score. Higher = matches the class name.</a:t>
+              <a:t>• PseCo에서의 역할: ROIHeadMLP의 512-d 출력을 CLIP 텍스트 피처와 비교해 분류.</a:t>
+            </a:r>
+          </a:p>
+          <a:p>
+            <a:pPr lvl="1"/>
+            <a:r>
+              <a:rPr sz="1500">
+                <a:solidFill>
+                  <a:srgbClr val="6B6B6B"/>
+                </a:solidFill>
+              </a:rPr>
+              <a:t>– dot(ROI_feature, text_feature) → 점수. 높을수록 클래스 이름과 매칭.</a:t>
             </a:r>
           </a:p>
           <a:p>
@@ -5702,29 +7060,29 @@
                   <a:srgbClr val="2A2A2A"/>
                 </a:solidFill>
               </a:rPr>
-              <a:t>• Subtle point: OpenAI CLIP weights were trained with QuickGELU activation, not standard GELU.</a:t>
-            </a:r>
-          </a:p>
-          <a:p>
-            <a:pPr lvl="1"/>
-            <a:r>
-              <a:rPr sz="1500">
-                <a:solidFill>
-                  <a:srgbClr val="6B6B6B"/>
-                </a:solidFill>
-              </a:rPr>
-              <a:t>– `open_clip.create_model('ViT-B-32')` defaults to standard GELU → text features drift silently.</a:t>
-            </a:r>
-          </a:p>
-          <a:p>
-            <a:pPr lvl="1"/>
-            <a:r>
-              <a:rPr sz="1500">
-                <a:solidFill>
-                  <a:srgbClr val="6B6B6B"/>
-                </a:solidFill>
-              </a:rPr>
-              <a:t>– Must use `'ViT-B-32-quickgelu'` variant. We learned this the hard way in Plan 3.</a:t>
+              <a:t>• 미묘한 지점: OpenAI CLIP 가중치는 QuickGELU 활성화로 학습됨 (표준 GELU 아님).</a:t>
+            </a:r>
+          </a:p>
+          <a:p>
+            <a:pPr lvl="1"/>
+            <a:r>
+              <a:rPr sz="1500">
+                <a:solidFill>
+                  <a:srgbClr val="6B6B6B"/>
+                </a:solidFill>
+              </a:rPr>
+              <a:t>– `open_clip.create_model('ViT-B-32')` 기본값은 표준 GELU → 텍스트 피처가 조용히 drift.</a:t>
+            </a:r>
+          </a:p>
+          <a:p>
+            <a:pPr lvl="1"/>
+            <a:r>
+              <a:rPr sz="1500">
+                <a:solidFill>
+                  <a:srgbClr val="6B6B6B"/>
+                </a:solidFill>
+              </a:rPr>
+              <a:t>– 반드시 `'ViT-B-32-quickgelu'` 변형을 써야 함 — Plan 3에서 이것을 놓쳐 큰 대가를 치름.</a:t>
             </a:r>
           </a:p>
         </p:txBody>
@@ -5775,7 +7133,7 @@
                   <a:srgbClr val="2E5F8A"/>
                 </a:solidFill>
               </a:rPr>
-              <a:t>Theoretical Components (3/3) — PseCo Pipeline (ICLR 2024)</a:t>
+              <a:t>이론적 구성 요소 (3/3) — PseCo 파이프라인 (ICLR 2024)</a:t>
             </a:r>
           </a:p>
         </p:txBody>
@@ -5809,7 +7167,7 @@
                   <a:srgbClr val="2A2A2A"/>
                 </a:solidFill>
               </a:rPr>
-              <a:t>• "Point, Segment, Count" (Huang et al., 2024).</a:t>
+              <a:t>• "Point, Segment, and Count" (Huang et al., 2024).</a:t>
             </a:r>
           </a:p>
           <a:p>
@@ -5820,40 +7178,40 @@
                   <a:srgbClr val="2A2A2A"/>
                 </a:solidFill>
               </a:rPr>
-              <a:t>• Three-stage inference on cached SAM features:</a:t>
-            </a:r>
-          </a:p>
-          <a:p>
-            <a:pPr lvl="1"/>
-            <a:r>
-              <a:rPr sz="1500">
-                <a:solidFill>
-                  <a:srgbClr val="6B6B6B"/>
-                </a:solidFill>
-              </a:rPr>
-              <a:t>– PointDecoder: dense heatmap → top-K candidate points (post-NMS).</a:t>
-            </a:r>
-          </a:p>
-          <a:p>
-            <a:pPr lvl="1"/>
-            <a:r>
-              <a:rPr sz="1500">
-                <a:solidFill>
-                  <a:srgbClr val="6B6B6B"/>
-                </a:solidFill>
-              </a:rPr>
-              <a:t>– SAM-as-proposal: for each point, SAM emits 5 mask/box hypotheses (varying anchor sizes).</a:t>
-            </a:r>
-          </a:p>
-          <a:p>
-            <a:pPr lvl="1"/>
-            <a:r>
-              <a:rPr sz="1500">
-                <a:solidFill>
-                  <a:srgbClr val="6B6B6B"/>
-                </a:solidFill>
-              </a:rPr>
-              <a:t>– ROIHeadMLP + CLIP: score each (region, text) pair → NMS → threshold.</a:t>
+              <a:t>• 캐시된 SAM 피처 위에서 3단계 추론:</a:t>
+            </a:r>
+          </a:p>
+          <a:p>
+            <a:pPr lvl="1"/>
+            <a:r>
+              <a:rPr sz="1500">
+                <a:solidFill>
+                  <a:srgbClr val="6B6B6B"/>
+                </a:solidFill>
+              </a:rPr>
+              <a:t>– PointDecoder: dense heatmap → top-K 후보 점 (자체 NMS 적용).</a:t>
+            </a:r>
+          </a:p>
+          <a:p>
+            <a:pPr lvl="1"/>
+            <a:r>
+              <a:rPr sz="1500">
+                <a:solidFill>
+                  <a:srgbClr val="6B6B6B"/>
+                </a:solidFill>
+              </a:rPr>
+              <a:t>– SAM을 proposal 생성기로 사용: 각 점에 대해 5개의 마스크·박스 가설 제안.</a:t>
+            </a:r>
+          </a:p>
+          <a:p>
+            <a:pPr lvl="1"/>
+            <a:r>
+              <a:rPr sz="1500">
+                <a:solidFill>
+                  <a:srgbClr val="6B6B6B"/>
+                </a:solidFill>
+              </a:rPr>
+              <a:t>– ROIHeadMLP + CLIP: 각 (영역, 텍스트) 쌍을 점수화 → NMS → threshold.</a:t>
             </a:r>
           </a:p>
           <a:p>
@@ -5864,40 +7222,40 @@
                   <a:srgbClr val="2A2A2A"/>
                 </a:solidFill>
               </a:rPr>
-              <a:t>• Why it works for counting:</a:t>
-            </a:r>
-          </a:p>
-          <a:p>
-            <a:pPr lvl="1"/>
-            <a:r>
-              <a:rPr sz="1500">
-                <a:solidFill>
-                  <a:srgbClr val="6B6B6B"/>
-                </a:solidFill>
-              </a:rPr>
-              <a:t>– Class-agnostic SAM handles novel domains (orchard) without retraining its encoder.</a:t>
-            </a:r>
-          </a:p>
-          <a:p>
-            <a:pPr lvl="1"/>
-            <a:r>
-              <a:rPr sz="1500">
-                <a:solidFill>
-                  <a:srgbClr val="6B6B6B"/>
-                </a:solidFill>
-              </a:rPr>
-              <a:t>– Text prompt decides what to count — no re-training needed to switch from "apples" to "bread rolls".</a:t>
-            </a:r>
-          </a:p>
-          <a:p>
-            <a:pPr lvl="1"/>
-            <a:r>
-              <a:rPr sz="1500">
-                <a:solidFill>
-                  <a:srgbClr val="6B6B6B"/>
-                </a:solidFill>
-              </a:rPr>
-              <a:t>– Decoupling: localization (SAM + PointDecoder) is shared; classification (MLP + CLIP) is swappable.</a:t>
+              <a:t>• 카운팅에 효과적인 이유:</a:t>
+            </a:r>
+          </a:p>
+          <a:p>
+            <a:pPr lvl="1"/>
+            <a:r>
+              <a:rPr sz="1500">
+                <a:solidFill>
+                  <a:srgbClr val="6B6B6B"/>
+                </a:solidFill>
+              </a:rPr>
+              <a:t>– 클래스 무관한 SAM이 과수원 같은 새 도메인을 인코더 재학습 없이 커버.</a:t>
+            </a:r>
+          </a:p>
+          <a:p>
+            <a:pPr lvl="1"/>
+            <a:r>
+              <a:rPr sz="1500">
+                <a:solidFill>
+                  <a:srgbClr val="6B6B6B"/>
+                </a:solidFill>
+              </a:rPr>
+              <a:t>– 텍스트 프롬프트가 "셀 대상"을 지정 — "apples" → "bread rolls" 전환 시 재학습 불필요.</a:t>
+            </a:r>
+          </a:p>
+          <a:p>
+            <a:pPr lvl="1"/>
+            <a:r>
+              <a:rPr sz="1500">
+                <a:solidFill>
+                  <a:srgbClr val="6B6B6B"/>
+                </a:solidFill>
+              </a:rPr>
+              <a:t>– 분리 구조: 위치 추정(SAM+PointDecoder)은 공유, 분류(MLP+CLIP)는 교체 가능.</a:t>
             </a:r>
           </a:p>
           <a:p>
@@ -5908,7 +7266,7 @@
                   <a:srgbClr val="2A2A2A"/>
                 </a:solidFill>
               </a:rPr>
-              <a:t>• Training target in upstream: BCE on pseudo-box IoU + CLIP-consistency loss (preserves alignment).</a:t>
+              <a:t>• Upstream 학습 목표: pseudo-box IoU에 대한 BCE + CLIP 일관성 손실(정렬 유지용).</a:t>
             </a:r>
           </a:p>
         </p:txBody>
@@ -5941,7 +7299,7 @@
                   <a:srgbClr val="6B6B6B"/>
                 </a:solidFill>
               </a:rPr>
-              <a:t>github.com/Hzzone/PseCo — reports MAE 16–20 on FSC-147 test split</a:t>
+              <a:t>github.com/Hzzone/PseCo — FSC-147 test split에서 MAE 16–20 보고</a:t>
             </a:r>
           </a:p>
         </p:txBody>
@@ -6002,7 +7360,7 @@
                   <a:srgbClr val="1F3B5C"/>
                 </a:solidFill>
               </a:rPr>
-              <a:t>Four Iterations on FSC-147 + Orchard</a:t>
+              <a:t>FSC-147 + 과수원 위에서의 네 번의 이터레이션</a:t>
             </a:r>
           </a:p>
         </p:txBody>
@@ -6053,7 +7411,7 @@
                   <a:srgbClr val="2E5F8A"/>
                 </a:solidFill>
               </a:rPr>
-              <a:t>Our Plan Timeline</a:t>
+              <a:t>우리의 Plan 타임라인</a:t>
             </a:r>
           </a:p>
         </p:txBody>
@@ -6087,7 +7445,7 @@
                   <a:srgbClr val="2A2A2A"/>
                 </a:solidFill>
               </a:rPr>
-              <a:t>• Plan 1 (Foundation): scaffolding, CLI, config, data diagnostics. No training.</a:t>
+              <a:t>• Plan 1 (Foundation): 스캐폴드, CLI, 설정, 데이터 진단. 학습 없음.</a:t>
             </a:r>
           </a:p>
           <a:p>
@@ -6098,7 +7456,7 @@
                   <a:srgbClr val="2A2A2A"/>
                 </a:solidFill>
               </a:rPr>
-              <a:t>• Plan 2 (Training infrastructure): SAM feature cache (8.7 GB fp16 for 4945 FSC-147 images), Runner, TensorBoard, checkpoints. Placeholder objective.</a:t>
+              <a:t>• Plan 2 (학습 인프라): SAM 피처 캐시 (FSC-147 4945장의 fp16 임베딩 8.7 GB), Runner, TensorBoard, 체크포인트. Placeholder objective.</a:t>
             </a:r>
           </a:p>
           <a:p>
@@ -6109,40 +7467,40 @@
                   <a:srgbClr val="2A2A2A"/>
                 </a:solidFill>
               </a:rPr>
-              <a:t>• Plan 3 (First real fine-tune): CLIP text prompts + pos/neg labels from box-point containment.</a:t>
-            </a:r>
-          </a:p>
-          <a:p>
-            <a:pPr lvl="1"/>
-            <a:r>
-              <a:rPr sz="1500">
-                <a:solidFill>
-                  <a:srgbClr val="6B6B6B"/>
-                </a:solidFill>
-              </a:rPr>
-              <a:t>– Three bugs caught: CUDA device mismatch, coordinate-system mismatch, QuickGELU variant mismatch.</a:t>
-            </a:r>
-          </a:p>
-          <a:p>
-            <a:pPr lvl="1"/>
-            <a:r>
-              <a:rPr sz="1500">
-                <a:solidFill>
-                  <a:srgbClr val="6B6B6B"/>
-                </a:solidFill>
-              </a:rPr>
-              <a:t>– Final FSC-147 val/mae = 47.62 with K=32 proposals. Beat 'predict-zero' baseline of 50.58.</a:t>
-            </a:r>
-          </a:p>
-          <a:p>
-            <a:pPr lvl="1"/>
-            <a:r>
-              <a:rPr sz="1500">
-                <a:solidFill>
-                  <a:srgbClr val="6B6B6B"/>
-                </a:solidFill>
-              </a:rPr>
-              <a:t>– Looked like a success at this point.</a:t>
+              <a:t>• Plan 3 (첫 실제 파인튜닝): CLIP 텍스트 프롬프트 + 점-박스 포함 기반 pos/neg 레이블.</a:t>
+            </a:r>
+          </a:p>
+          <a:p>
+            <a:pPr lvl="1"/>
+            <a:r>
+              <a:rPr sz="1500">
+                <a:solidFill>
+                  <a:srgbClr val="6B6B6B"/>
+                </a:solidFill>
+              </a:rPr>
+              <a:t>– 발견한 버그 3종: CUDA device mismatch, 좌표계 mismatch, QuickGELU 변형 mismatch.</a:t>
+            </a:r>
+          </a:p>
+          <a:p>
+            <a:pPr lvl="1"/>
+            <a:r>
+              <a:rPr sz="1500">
+                <a:solidFill>
+                  <a:srgbClr val="6B6B6B"/>
+                </a:solidFill>
+              </a:rPr>
+              <a:t>– K=32 proposal로 FSC-147 val/mae = 47.62 달성. "predict-zero" baseline 50.58 돌파.</a:t>
+            </a:r>
+          </a:p>
+          <a:p>
+            <a:pPr lvl="1"/>
+            <a:r>
+              <a:rPr sz="1500">
+                <a:solidFill>
+                  <a:srgbClr val="6B6B6B"/>
+                </a:solidFill>
+              </a:rPr>
+              <a:t>– 이 시점에서는 성공처럼 보였음.</a:t>
             </a:r>
           </a:p>
           <a:p>
@@ -6153,29 +7511,29 @@
                   <a:srgbClr val="2A2A2A"/>
                 </a:solidFill>
               </a:rPr>
-              <a:t>• Plan 4 (Orchard reality check): four hand-counted orchard images exposed Plan 3's hidden failure.</a:t>
-            </a:r>
-          </a:p>
-          <a:p>
-            <a:pPr lvl="1"/>
-            <a:r>
-              <a:rPr sz="1500">
-                <a:solidFill>
-                  <a:srgbClr val="6B6B6B"/>
-                </a:solidFill>
-              </a:rPr>
-              <a:t>– Pivoted to upstream MLP + prompt engineering + SAM anchor tuning.</a:t>
-            </a:r>
-          </a:p>
-          <a:p>
-            <a:pPr lvl="1"/>
-            <a:r>
-              <a:rPr sz="1500">
-                <a:solidFill>
-                  <a:srgbClr val="6B6B6B"/>
-                </a:solidFill>
-              </a:rPr>
-              <a:t>– Final orchard MAE = 11.75 without any fine-tuning.</a:t>
+              <a:t>• Plan 4 (과수원 실전 검증): 직접 센 과수원 이미지 4장이 Plan 3의 숨은 실패를 드러냄.</a:t>
+            </a:r>
+          </a:p>
+          <a:p>
+            <a:pPr lvl="1"/>
+            <a:r>
+              <a:rPr sz="1500">
+                <a:solidFill>
+                  <a:srgbClr val="6B6B6B"/>
+                </a:solidFill>
+              </a:rPr>
+              <a:t>– 파인튜닝 포기 → upstream MLP + 프롬프트 엔지니어링 + SAM anchor 튜닝으로 피봇.</a:t>
+            </a:r>
+          </a:p>
+          <a:p>
+            <a:pPr lvl="1"/>
+            <a:r>
+              <a:rPr sz="1500">
+                <a:solidFill>
+                  <a:srgbClr val="6B6B6B"/>
+                </a:solidFill>
+              </a:rPr>
+              <a:t>– 최종 과수원 MAE 11.75 — 파인튜닝 없이 달성.</a:t>
             </a:r>
           </a:p>
         </p:txBody>
@@ -6226,7 +7584,7 @@
                   <a:srgbClr val="2E5F8A"/>
                 </a:solidFill>
               </a:rPr>
-              <a:t>Iteration-by-Iteration Numbers</a:t>
+              <a:t>이터레이션별 수치</a:t>
             </a:r>
           </a:p>
         </p:txBody>
@@ -6267,7 +7625,7 @@
                             <a:srgbClr val="FFFFFF"/>
                           </a:solidFill>
                         </a:rPr>
-                        <a:t>Version</a:t>
+                        <a:t>버전</a:t>
                       </a:r>
                     </a:p>
                   </a:txBody>
@@ -6309,7 +7667,7 @@
                             <a:srgbClr val="FFFFFF"/>
                           </a:solidFill>
                         </a:rPr>
-                        <a:t>Orchard MAE (4 imgs)</a:t>
+                        <a:t>과수원 MAE (4장)</a:t>
                       </a:r>
                     </a:p>
                   </a:txBody>
@@ -6330,7 +7688,7 @@
                             <a:srgbClr val="FFFFFF"/>
                           </a:solidFill>
                         </a:rPr>
-                        <a:t>Takeaway</a:t>
+                        <a:t>교훈</a:t>
                       </a:r>
                     </a:p>
                   </a:txBody>
@@ -6370,7 +7728,7 @@
                             <a:srgbClr val="2A2A2A"/>
                           </a:solidFill>
                         </a:rPr>
-                        <a:t>50.58 (deg.)</a:t>
+                        <a:t>50.58 (축퇴)</a:t>
                       </a:r>
                     </a:p>
                   </a:txBody>
@@ -6404,7 +7762,7 @@
                             <a:srgbClr val="2A2A2A"/>
                           </a:solidFill>
                         </a:rPr>
-                        <a:t>degenerate: predicts 0 always</a:t>
+                        <a:t>항상 0만 예측</a:t>
                       </a:r>
                     </a:p>
                   </a:txBody>
@@ -6486,7 +7844,7 @@
                             <a:srgbClr val="2A2A2A"/>
                           </a:solidFill>
                         </a:rPr>
-                        <a:t>coord-system bug</a:t>
+                        <a:t>좌표계 버그</a:t>
                       </a:r>
                     </a:p>
                   </a:txBody>
@@ -6560,7 +7918,7 @@
                             <a:srgbClr val="2A2A2A"/>
                           </a:solidFill>
                         </a:rPr>
-                        <a:t>marginal</a:t>
+                        <a:t>미미</a:t>
                       </a:r>
                     </a:p>
                   </a:txBody>
@@ -6579,7 +7937,7 @@
                             <a:srgbClr val="2A2A2A"/>
                           </a:solidFill>
                         </a:rPr>
-                        <a:t>Plan 3 v3 (+ coord fix)</a:t>
+                        <a:t>Plan 3 v3 (+ 좌표 수정)</a:t>
                       </a:r>
                     </a:p>
                   </a:txBody>
@@ -6642,7 +8000,7 @@
                             <a:srgbClr val="2A2A2A"/>
                           </a:solidFill>
                         </a:rPr>
-                        <a:t>coord fix dominant</a:t>
+                        <a:t>좌표 수정이 지배적</a:t>
                       </a:r>
                     </a:p>
                   </a:txBody>
@@ -6716,7 +8074,7 @@
                             <a:srgbClr val="2A2A2A"/>
                           </a:solidFill>
                         </a:rPr>
-                        <a:t>prompt-agnostic in prod</a:t>
+                        <a:t>프로덕션에서 prompt-agnostic</a:t>
                       </a:r>
                     </a:p>
                   </a:txBody>
@@ -6735,7 +8093,7 @@
                             <a:srgbClr val="2A2A2A"/>
                           </a:solidFill>
                         </a:rPr>
-                        <a:t>Plan 4 upstream MLP (default)</a:t>
+                        <a:t>Plan 4 upstream MLP (기본)</a:t>
                       </a:r>
                     </a:p>
                   </a:txBody>
@@ -6798,7 +8156,7 @@
                             <a:srgbClr val="2A2A2A"/>
                           </a:solidFill>
                         </a:rPr>
-                        <a:t>zero training, still competitive</a:t>
+                        <a:t>학습 0, 충분히 경쟁적</a:t>
                       </a:r>
                     </a:p>
                   </a:txBody>
@@ -6821,7 +8179,7 @@
                             <a:srgbClr val="2A2A2A"/>
                           </a:solidFill>
                         </a:rPr>
-                        <a:t>Plan 4 + threshold tune</a:t>
+                        <a:t>Plan 4 + threshold 튜닝</a:t>
                       </a:r>
                     </a:p>
                   </a:txBody>
@@ -6872,7 +8230,7 @@
                             <a:srgbClr val="2A2A2A"/>
                           </a:solidFill>
                         </a:rPr>
-                        <a:t>small grid-search gain</a:t>
+                        <a:t>그리드 서치 소폭 개선</a:t>
                       </a:r>
                     </a:p>
                   </a:txBody>
@@ -6954,7 +8312,7 @@
                             <a:srgbClr val="2A2A2A"/>
                           </a:solidFill>
                         </a:rPr>
-                        <a:t>scale matters</a:t>
+                        <a:t>스케일이 핵심</a:t>
                       </a:r>
                     </a:p>
                   </a:txBody>

</xml_diff>